<commit_message>
Finalize English contest media and private-source delivery for 0.3.1
</commit_message>
<xml_diff>
--- a/docs/submission/FOR-THE-RECORD-pitch.pptx
+++ b/docs/submission/FOR-THE-RECORD-pitch.pptx
@@ -2,20 +2,20 @@
 <file path=ppt/presentation.xml><?xml version="1.0" encoding="utf-8"?>
 <p:presentation xmlns:p="http://schemas.openxmlformats.org/presentationml/2006/main">
   <p:sldMasterIdLst>
-    <p:sldMasterId xmlns:r="http://schemas.openxmlformats.org/officeDocument/2006/relationships" id="2147483648" r:id="R8bb48a0adddf4975"/>
+    <p:sldMasterId xmlns:r="http://schemas.openxmlformats.org/officeDocument/2006/relationships" id="2147483648" r:id="R2fa538909e6a4241"/>
   </p:sldMasterIdLst>
   <p:notesMasterIdLst>
-    <p:notesMasterId xmlns:r="http://schemas.openxmlformats.org/officeDocument/2006/relationships" r:id="R996ad16c4b464aec"/>
+    <p:notesMasterId xmlns:r="http://schemas.openxmlformats.org/officeDocument/2006/relationships" r:id="R3cd98fe351d34856"/>
   </p:notesMasterIdLst>
   <p:sldIdLst>
-    <p:sldId xmlns:r="http://schemas.openxmlformats.org/officeDocument/2006/relationships" id="256" r:id="Rd910b73bd73d4413"/>
-    <p:sldId xmlns:r="http://schemas.openxmlformats.org/officeDocument/2006/relationships" id="257" r:id="Ra773f99cf0a34f8c"/>
-    <p:sldId xmlns:r="http://schemas.openxmlformats.org/officeDocument/2006/relationships" id="258" r:id="R2fc4f088d16b4a5b"/>
-    <p:sldId xmlns:r="http://schemas.openxmlformats.org/officeDocument/2006/relationships" id="259" r:id="R94b1be453b9d4739"/>
-    <p:sldId xmlns:r="http://schemas.openxmlformats.org/officeDocument/2006/relationships" id="260" r:id="R789525a00c864af9"/>
-    <p:sldId xmlns:r="http://schemas.openxmlformats.org/officeDocument/2006/relationships" id="261" r:id="R4acccad6166b432b"/>
-    <p:sldId xmlns:r="http://schemas.openxmlformats.org/officeDocument/2006/relationships" id="262" r:id="R7062c5a05d0d44df"/>
-    <p:sldId xmlns:r="http://schemas.openxmlformats.org/officeDocument/2006/relationships" id="263" r:id="R27a4f8ccc01447e8"/>
+    <p:sldId xmlns:r="http://schemas.openxmlformats.org/officeDocument/2006/relationships" id="256" r:id="R513009ceb976458a"/>
+    <p:sldId xmlns:r="http://schemas.openxmlformats.org/officeDocument/2006/relationships" id="257" r:id="Rbd367173123543c9"/>
+    <p:sldId xmlns:r="http://schemas.openxmlformats.org/officeDocument/2006/relationships" id="258" r:id="Re318fee9057a49c0"/>
+    <p:sldId xmlns:r="http://schemas.openxmlformats.org/officeDocument/2006/relationships" id="259" r:id="Rc237c070bf5c4213"/>
+    <p:sldId xmlns:r="http://schemas.openxmlformats.org/officeDocument/2006/relationships" id="260" r:id="R3006deb466d44b07"/>
+    <p:sldId xmlns:r="http://schemas.openxmlformats.org/officeDocument/2006/relationships" id="261" r:id="Ra423f6d356c342dd"/>
+    <p:sldId xmlns:r="http://schemas.openxmlformats.org/officeDocument/2006/relationships" id="262" r:id="Re5c9bced046d4397"/>
+    <p:sldId xmlns:r="http://schemas.openxmlformats.org/officeDocument/2006/relationships" id="263" r:id="R5430ccad8c03442b"/>
   </p:sldIdLst>
   <p:sldSz cx="12192000" cy="6858000"/>
   <p:notesSz cx="6858000" cy="9144000"/>
@@ -589,7 +589,7 @@
           <a:lstStyle xmlns:a="http://schemas.openxmlformats.org/drawingml/2006/main"/>
           <a:p xmlns:a="http://schemas.openxmlformats.org/drawingml/2006/main">
             <a:r>
-              <a:t>Screenshot is from the current app and shows demonstration records if present. Core workflow evidence is in lib/ui/home.dart, focus.dart, books.dart and the domain controller. See current release validation for the exact tested version.</a:t>
+              <a:t>Detail crop of screenshot 12-return-next-step-en.png from the passed Android integration test. The saved next action, Test the same flow with large text, becomes the next intention via Continue from your bookmark. It uses actual SQLite persistence and native elapsed time. No account or wallet is needed for this local workflow.</a:t>
             </a:r>
           </a:p>
         </p:txBody>
@@ -659,7 +659,7 @@
           <a:lstStyle xmlns:a="http://schemas.openxmlformats.org/drawingml/2006/main"/>
           <a:p xmlns:a="http://schemas.openxmlformats.org/drawingml/2006/main">
             <a:r>
-              <a:t>The direct preview uses native Mobile Wallet Adapter and public RPC for read-only activity. Source: lib/data/direct_activity.dart and lib/data/remote.dart. The local parser recognizes a narrow set of Jupiter v6 classic SPL swaps. Unsupported formats remain unsupported. Public RPC has limits and is not production infrastructure: https://solana.com/docs/references/clusters . A successful real-wallet run remains unverified.</a:t>
+              <a:t>Detail crop of screenshot 19-sample-reopen-en.png. This sequence uses a synthetic transaction in an isolated integration test and proves UI/persistence only. The release APK contains no fixture mode. The direct preview uses native MWA and public RPC for read-only activity. A separate manual Android emulator run with the official Solana mock wallet approved a connection and read empty mainnet history. Physical Seeker and a supported live event-to-reflection flow remain unverified. The parser handles a narrow set of Jupiter v6 classic SPL swaps; unsupported formats remain unsupported. Public RPC has limits: https://solana.com/docs/references/clusters .</a:t>
             </a:r>
           </a:p>
         </p:txBody>
@@ -869,7 +869,7 @@
           <a:lstStyle xmlns:a="http://schemas.openxmlformats.org/drawingml/2006/main"/>
           <a:p xmlns:a="http://schemas.openxmlformats.org/drawingml/2006/main">
             <a:r>
-              <a:t>Current version 0.3.0 evidence: docs/VALIDATION_0.3.0.md. Flutter analysis clean, 84 Flutter tests and 40 optional-backend tests pass. Eight languages fit 360 logical pixels at 200 percent text scale. Android emulator integration verifies local SQLite/native clock and actual no-wallet handling. Public RPC getVersion establishes reachability only. No production-signing key, live wallet success, physical-Seeker success, user traction or mainnet SKR payment is asserted.</a:t>
+              <a:t>Consult the release evidence for the exact 0.3.1 checks. Automated parser/logic checks and Android emulator capture do not establish physical-device wallet success. Public RPC reachability alone does not establish the wallet-to-reflection flow. No production-signing key, live wallet success, physical-Seeker success, user traction or mainnet SKR payment is asserted.</a:t>
             </a:r>
           </a:p>
         </p:txBody>
@@ -1007,7 +1007,7 @@
   </p:cSld>
   <p:clrMap bg1="lt1" tx1="dk1" bg2="lt2" tx2="dk2" accent1="accent1" accent2="accent2" accent3="accent3" accent4="accent4" accent5="accent5" accent6="accent6" hlink="hlink" folHlink="folHlink"/>
   <p:sldLayoutIdLst>
-    <p:sldLayoutId xmlns:r="http://schemas.openxmlformats.org/officeDocument/2006/relationships" id="2147483649" r:id="R4f6d371a10044e40"/>
+    <p:sldLayoutId xmlns:r="http://schemas.openxmlformats.org/officeDocument/2006/relationships" id="2147483649" r:id="R7fe5019820cb410d"/>
   </p:sldLayoutIdLst>
   <p:txStyles>
     <p:titleStyle>
@@ -1540,7 +1540,7 @@
     <p:bg>
       <p:bgPr>
         <a:solidFill xmlns:a="http://schemas.openxmlformats.org/drawingml/2006/main">
-          <a:srgbClr val="096B61"/>
+          <a:srgbClr val="191F28"/>
         </a:solidFill>
       </p:bgPr>
     </p:bg>
@@ -1558,7 +1558,7 @@
           <p:cNvPr id="6" name="">
             <a:extLst xmlns:a="http://schemas.openxmlformats.org/drawingml/2006/main">
               <a:ext uri="{FF2B5EF4-FFF2-40B4-BE49-F238E27FC236}">
-                <a16:creationId xmlns:a16="http://schemas.microsoft.com/office/drawing/2014/main" id="{2C5198FD-0F29-417C-A1FC-C0CDE214F353}"/>
+                <a16:creationId xmlns:a16="http://schemas.microsoft.com/office/drawing/2014/main" id="{38AE2C48-46FF-41ED-933C-BD65C30B7A7F}"/>
               </a:ext>
             </a:extLst>
           </p:cNvPr>
@@ -1589,21 +1589,21 @@
             <a:pPr>
               <a:defRPr sz="7875" b="1">
                 <a:solidFill>
-                  <a:srgbClr val="F2FFCE"/>
-                </a:solidFill>
-                <a:latin typeface="Arial"/>
-                <a:ea typeface="Arial"/>
-                <a:cs typeface="Arial"/>
+                  <a:srgbClr val="FFFFFF"/>
+                </a:solidFill>
+                <a:latin typeface="Segoe UI"/>
+                <a:ea typeface="Segoe UI"/>
+                <a:cs typeface="Segoe UI"/>
               </a:defRPr>
             </a:pPr>
             <a:r>
               <a:rPr sz="7875" b="1">
                 <a:solidFill>
-                  <a:srgbClr val="F2FFCE"/>
-                </a:solidFill>
-                <a:latin typeface="Arial"/>
-                <a:ea typeface="Arial"/>
-                <a:cs typeface="Arial"/>
+                  <a:srgbClr val="FFFFFF"/>
+                </a:solidFill>
+                <a:latin typeface="Segoe UI"/>
+                <a:ea typeface="Segoe UI"/>
+                <a:cs typeface="Segoe UI"/>
               </a:rPr>
               <a:t>FOR THE</a:t>
             </a:r>
@@ -1612,21 +1612,21 @@
             <a:pPr>
               <a:defRPr sz="7875" b="1">
                 <a:solidFill>
-                  <a:srgbClr val="F2FFCE"/>
-                </a:solidFill>
-                <a:latin typeface="Arial"/>
-                <a:ea typeface="Arial"/>
-                <a:cs typeface="Arial"/>
+                  <a:srgbClr val="FFFFFF"/>
+                </a:solidFill>
+                <a:latin typeface="Segoe UI"/>
+                <a:ea typeface="Segoe UI"/>
+                <a:cs typeface="Segoe UI"/>
               </a:defRPr>
             </a:pPr>
             <a:r>
               <a:rPr sz="7875" b="1">
                 <a:solidFill>
-                  <a:srgbClr val="F2FFCE"/>
-                </a:solidFill>
-                <a:latin typeface="Arial"/>
-                <a:ea typeface="Arial"/>
-                <a:cs typeface="Arial"/>
+                  <a:srgbClr val="FFFFFF"/>
+                </a:solidFill>
+                <a:latin typeface="Segoe UI"/>
+                <a:ea typeface="Segoe UI"/>
+                <a:cs typeface="Segoe UI"/>
               </a:rPr>
               <a:t>RECORD</a:t>
             </a:r>
@@ -1638,7 +1638,7 @@
           <p:cNvPr id="2" name="">
             <a:extLst xmlns:a="http://schemas.openxmlformats.org/drawingml/2006/main">
               <a:ext uri="{FF2B5EF4-FFF2-40B4-BE49-F238E27FC236}">
-                <a16:creationId xmlns:a16="http://schemas.microsoft.com/office/drawing/2014/main" id="{58C98E9B-1F19-47B3-9818-6717AB5F4C74}"/>
+                <a16:creationId xmlns:a16="http://schemas.microsoft.com/office/drawing/2014/main" id="{551471FE-59B7-4F75-92C5-0FFE9ECA3021}"/>
               </a:ext>
             </a:extLst>
           </p:cNvPr>
@@ -1669,21 +1669,21 @@
             <a:pPr>
               <a:defRPr sz="2850" b="0">
                 <a:solidFill>
-                  <a:srgbClr val="FFFEFA"/>
-                </a:solidFill>
-                <a:latin typeface="Arial"/>
-                <a:ea typeface="Arial"/>
-                <a:cs typeface="Arial"/>
+                  <a:srgbClr val="FFFFFF"/>
+                </a:solidFill>
+                <a:latin typeface="Segoe UI"/>
+                <a:ea typeface="Segoe UI"/>
+                <a:cs typeface="Segoe UI"/>
               </a:defRPr>
             </a:pPr>
             <a:r>
               <a:rPr sz="2850" b="0">
                 <a:solidFill>
-                  <a:srgbClr val="FFFEFA"/>
-                </a:solidFill>
-                <a:latin typeface="Arial"/>
-                <a:ea typeface="Arial"/>
-                <a:cs typeface="Arial"/>
+                  <a:srgbClr val="FFFFFF"/>
+                </a:solidFill>
+                <a:latin typeface="Segoe UI"/>
+                <a:ea typeface="Segoe UI"/>
+                <a:cs typeface="Segoe UI"/>
               </a:rPr>
               <a:t>“For the record, this is why I did it.”</a:t>
             </a:r>
@@ -1695,7 +1695,7 @@
           <p:cNvPr id="3" name="">
             <a:extLst xmlns:a="http://schemas.openxmlformats.org/drawingml/2006/main">
               <a:ext uri="{FF2B5EF4-FFF2-40B4-BE49-F238E27FC236}">
-                <a16:creationId xmlns:a16="http://schemas.microsoft.com/office/drawing/2014/main" id="{879129CA-3FB6-4ADF-8B72-6E8BDAF7AEB3}"/>
+                <a16:creationId xmlns:a16="http://schemas.microsoft.com/office/drawing/2014/main" id="{92192442-7A7C-403B-8F32-C05303B4D03A}"/>
               </a:ext>
             </a:extLst>
           </p:cNvPr>
@@ -1726,21 +1726,21 @@
             <a:pPr>
               <a:defRPr sz="2100" b="0">
                 <a:solidFill>
-                  <a:srgbClr val="FFFEFA"/>
-                </a:solidFill>
-                <a:latin typeface="Arial"/>
-                <a:ea typeface="Arial"/>
-                <a:cs typeface="Arial"/>
+                  <a:srgbClr val="FFFFFF"/>
+                </a:solidFill>
+                <a:latin typeface="Segoe UI"/>
+                <a:ea typeface="Segoe UI"/>
+                <a:cs typeface="Segoe UI"/>
               </a:defRPr>
             </a:pPr>
             <a:r>
               <a:rPr sz="2100" b="0">
                 <a:solidFill>
-                  <a:srgbClr val="FFFEFA"/>
-                </a:solidFill>
-                <a:latin typeface="Arial"/>
-                <a:ea typeface="Arial"/>
-                <a:cs typeface="Arial"/>
+                  <a:srgbClr val="FFFFFF"/>
+                </a:solidFill>
+                <a:latin typeface="Segoe UI"/>
+                <a:ea typeface="Segoe UI"/>
+                <a:cs typeface="Segoe UI"/>
               </a:rPr>
               <a:t>A private Android journal for work and wallet decisions</a:t>
             </a:r>
@@ -1752,7 +1752,7 @@
           <p:cNvPr id="4" name="">
             <a:extLst xmlns:a="http://schemas.openxmlformats.org/drawingml/2006/main">
               <a:ext uri="{FF2B5EF4-FFF2-40B4-BE49-F238E27FC236}">
-                <a16:creationId xmlns:a16="http://schemas.microsoft.com/office/drawing/2014/main" id="{46AB9B01-3804-4E5B-AA51-696EAC81D800}"/>
+                <a16:creationId xmlns:a16="http://schemas.microsoft.com/office/drawing/2014/main" id="{2720ADDE-93FC-4A48-8E8E-46EAB73D0421}"/>
               </a:ext>
             </a:extLst>
           </p:cNvPr>
@@ -1783,23 +1783,23 @@
             <a:pPr>
               <a:defRPr sz="1500" b="0">
                 <a:solidFill>
-                  <a:srgbClr val="F2FFCE"/>
-                </a:solidFill>
-                <a:latin typeface="Arial"/>
-                <a:ea typeface="Arial"/>
-                <a:cs typeface="Arial"/>
+                  <a:srgbClr val="D5F56B"/>
+                </a:solidFill>
+                <a:latin typeface="Segoe UI"/>
+                <a:ea typeface="Segoe UI"/>
+                <a:cs typeface="Segoe UI"/>
               </a:defRPr>
             </a:pPr>
             <a:r>
               <a:rPr sz="1500" b="0">
                 <a:solidFill>
-                  <a:srgbClr val="F2FFCE"/>
-                </a:solidFill>
-                <a:latin typeface="Arial"/>
-                <a:ea typeface="Arial"/>
-                <a:cs typeface="Arial"/>
-              </a:rPr>
-              <a:t>CLOCK IN 2026  /  Preview 0.3.0</a:t>
+                  <a:srgbClr val="D5F56B"/>
+                </a:solidFill>
+                <a:latin typeface="Segoe UI"/>
+                <a:ea typeface="Segoe UI"/>
+                <a:cs typeface="Segoe UI"/>
+              </a:rPr>
+              <a:t>CLOCK IN 2026  /  Preview 0.3.1</a:t>
             </a:r>
           </a:p>
         </p:txBody>
@@ -1813,7 +1813,7 @@
           <p:nvPr/>
         </p:nvPicPr>
         <p:blipFill>
-          <a:blip xmlns:r="http://schemas.openxmlformats.org/officeDocument/2006/relationships" xmlns:a="http://schemas.openxmlformats.org/drawingml/2006/main" r:embed="R945c9b07ef1d4e4f"/>
+          <a:blip xmlns:r="http://schemas.openxmlformats.org/officeDocument/2006/relationships" xmlns:a="http://schemas.openxmlformats.org/drawingml/2006/main" r:embed="Rfb3baa647d3e4bdf"/>
           <a:stretch xmlns:a="http://schemas.openxmlformats.org/drawingml/2006/main"/>
         </p:blipFill>
         <p:spPr>
@@ -1829,7 +1829,7 @@
     </p:spTree>
     <p:extLst>
       <p:ext uri="{BB962C8B-B14F-4D97-AF65-F5344CB8AC3E}">
-        <p14:creationId xmlns:p14="http://schemas.microsoft.com/office/powerpoint/2010/main" val="1930266609"/>
+        <p14:creationId xmlns:p14="http://schemas.microsoft.com/office/powerpoint/2010/main" val="1103961998"/>
       </p:ext>
     </p:extLst>
   </p:cSld>
@@ -1842,7 +1842,7 @@
     <p:bg>
       <p:bgPr>
         <a:solidFill xmlns:a="http://schemas.openxmlformats.org/drawingml/2006/main">
-          <a:srgbClr val="FFFEFA"/>
+          <a:srgbClr val="FFFFFF"/>
         </a:solidFill>
       </p:bgPr>
     </p:bg>
@@ -1860,7 +1860,7 @@
           <p:cNvPr id="7" name="">
             <a:extLst xmlns:a="http://schemas.openxmlformats.org/drawingml/2006/main">
               <a:ext uri="{FF2B5EF4-FFF2-40B4-BE49-F238E27FC236}">
-                <a16:creationId xmlns:a16="http://schemas.microsoft.com/office/drawing/2014/main" id="{3AB6DB59-CA82-4995-8A2B-09966F5FAA3F}"/>
+                <a16:creationId xmlns:a16="http://schemas.microsoft.com/office/drawing/2014/main" id="{F051875E-2B91-4E75-84CC-A549D9FCC0A8}"/>
               </a:ext>
             </a:extLst>
           </p:cNvPr>
@@ -1891,21 +1891,21 @@
             <a:pPr>
               <a:defRPr sz="4200" b="1">
                 <a:solidFill>
-                  <a:srgbClr val="152F2C"/>
-                </a:solidFill>
-                <a:latin typeface="Arial"/>
-                <a:ea typeface="Arial"/>
-                <a:cs typeface="Arial"/>
+                  <a:srgbClr val="191F28"/>
+                </a:solidFill>
+                <a:latin typeface="Segoe UI"/>
+                <a:ea typeface="Segoe UI"/>
+                <a:cs typeface="Segoe UI"/>
               </a:defRPr>
             </a:pPr>
             <a:r>
               <a:rPr sz="4200" b="1">
                 <a:solidFill>
-                  <a:srgbClr val="152F2C"/>
-                </a:solidFill>
-                <a:latin typeface="Arial"/>
-                <a:ea typeface="Arial"/>
-                <a:cs typeface="Arial"/>
+                  <a:srgbClr val="191F28"/>
+                </a:solidFill>
+                <a:latin typeface="Segoe UI"/>
+                <a:ea typeface="Segoe UI"/>
+                <a:cs typeface="Segoe UI"/>
               </a:rPr>
               <a:t>The reason is easy to lose</a:t>
             </a:r>
@@ -1917,7 +1917,7 @@
           <p:cNvPr id="2" name="">
             <a:extLst xmlns:a="http://schemas.openxmlformats.org/drawingml/2006/main">
               <a:ext uri="{FF2B5EF4-FFF2-40B4-BE49-F238E27FC236}">
-                <a16:creationId xmlns:a16="http://schemas.microsoft.com/office/drawing/2014/main" id="{AC1DDE02-A54E-400C-ADB4-1E9DF2BA5FEF}"/>
+                <a16:creationId xmlns:a16="http://schemas.microsoft.com/office/drawing/2014/main" id="{33289CE5-7010-44A7-9F02-4625AC543960}"/>
               </a:ext>
             </a:extLst>
           </p:cNvPr>
@@ -1948,21 +1948,21 @@
             <a:pPr>
               <a:defRPr sz="2850" b="1">
                 <a:solidFill>
-                  <a:srgbClr val="096B61"/>
-                </a:solidFill>
-                <a:latin typeface="Arial"/>
-                <a:ea typeface="Arial"/>
-                <a:cs typeface="Arial"/>
+                  <a:srgbClr val="007F78"/>
+                </a:solidFill>
+                <a:latin typeface="Segoe UI"/>
+                <a:ea typeface="Segoe UI"/>
+                <a:cs typeface="Segoe UI"/>
               </a:defRPr>
             </a:pPr>
             <a:r>
               <a:rPr sz="2850" b="1">
                 <a:solidFill>
-                  <a:srgbClr val="096B61"/>
-                </a:solidFill>
-                <a:latin typeface="Arial"/>
-                <a:ea typeface="Arial"/>
-                <a:cs typeface="Arial"/>
+                  <a:srgbClr val="007F78"/>
+                </a:solidFill>
+                <a:latin typeface="Segoe UI"/>
+                <a:ea typeface="Segoe UI"/>
+                <a:cs typeface="Segoe UI"/>
               </a:rPr>
               <a:t>A finished task shows an outcome.</a:t>
             </a:r>
@@ -1971,21 +1971,21 @@
             <a:pPr>
               <a:defRPr sz="2850" b="1">
                 <a:solidFill>
-                  <a:srgbClr val="096B61"/>
-                </a:solidFill>
-                <a:latin typeface="Arial"/>
-                <a:ea typeface="Arial"/>
-                <a:cs typeface="Arial"/>
+                  <a:srgbClr val="007F78"/>
+                </a:solidFill>
+                <a:latin typeface="Segoe UI"/>
+                <a:ea typeface="Segoe UI"/>
+                <a:cs typeface="Segoe UI"/>
               </a:defRPr>
             </a:pPr>
             <a:r>
               <a:rPr sz="2850" b="1">
                 <a:solidFill>
-                  <a:srgbClr val="096B61"/>
-                </a:solidFill>
-                <a:latin typeface="Arial"/>
-                <a:ea typeface="Arial"/>
-                <a:cs typeface="Arial"/>
+                  <a:srgbClr val="007F78"/>
+                </a:solidFill>
+                <a:latin typeface="Segoe UI"/>
+                <a:ea typeface="Segoe UI"/>
+                <a:cs typeface="Segoe UI"/>
               </a:rPr>
               <a:t>A transaction shows an event.</a:t>
             </a:r>
@@ -1997,7 +1997,7 @@
           <p:cNvPr id="3" name="">
             <a:extLst xmlns:a="http://schemas.openxmlformats.org/drawingml/2006/main">
               <a:ext uri="{FF2B5EF4-FFF2-40B4-BE49-F238E27FC236}">
-                <a16:creationId xmlns:a16="http://schemas.microsoft.com/office/drawing/2014/main" id="{85874AC8-A8C6-4A72-B644-169CE1AEA11D}"/>
+                <a16:creationId xmlns:a16="http://schemas.microsoft.com/office/drawing/2014/main" id="{A9E1918B-2D1E-4681-82E9-E49C6D9AF384}"/>
               </a:ext>
             </a:extLst>
           </p:cNvPr>
@@ -2028,21 +2028,21 @@
             <a:pPr>
               <a:defRPr sz="2700" b="0">
                 <a:solidFill>
-                  <a:srgbClr val="152F2C"/>
-                </a:solidFill>
-                <a:latin typeface="Arial"/>
-                <a:ea typeface="Arial"/>
-                <a:cs typeface="Arial"/>
+                  <a:srgbClr val="191F28"/>
+                </a:solidFill>
+                <a:latin typeface="Segoe UI"/>
+                <a:ea typeface="Segoe UI"/>
+                <a:cs typeface="Segoe UI"/>
               </a:defRPr>
             </a:pPr>
             <a:r>
               <a:rPr sz="2700" b="0">
                 <a:solidFill>
-                  <a:srgbClr val="152F2C"/>
-                </a:solidFill>
-                <a:latin typeface="Arial"/>
-                <a:ea typeface="Arial"/>
-                <a:cs typeface="Arial"/>
+                  <a:srgbClr val="191F28"/>
+                </a:solidFill>
+                <a:latin typeface="Segoe UI"/>
+                <a:ea typeface="Segoe UI"/>
+                <a:cs typeface="Segoe UI"/>
               </a:rPr>
               <a:t>The thinking behind either can disappear.</a:t>
             </a:r>
@@ -2054,7 +2054,7 @@
           <p:cNvPr id="4" name="">
             <a:extLst xmlns:a="http://schemas.openxmlformats.org/drawingml/2006/main">
               <a:ext uri="{FF2B5EF4-FFF2-40B4-BE49-F238E27FC236}">
-                <a16:creationId xmlns:a16="http://schemas.microsoft.com/office/drawing/2014/main" id="{DD2FF91F-7947-4A22-86B6-F872940426EF}"/>
+                <a16:creationId xmlns:a16="http://schemas.microsoft.com/office/drawing/2014/main" id="{DF527658-E950-4A73-A96D-3B1A0A69EB82}"/>
               </a:ext>
             </a:extLst>
           </p:cNvPr>
@@ -2085,21 +2085,21 @@
             <a:pPr>
               <a:defRPr sz="2250" b="0">
                 <a:solidFill>
-                  <a:srgbClr val="152F2C"/>
-                </a:solidFill>
-                <a:latin typeface="Arial"/>
-                <a:ea typeface="Arial"/>
-                <a:cs typeface="Arial"/>
+                  <a:srgbClr val="191F28"/>
+                </a:solidFill>
+                <a:latin typeface="Segoe UI"/>
+                <a:ea typeface="Segoe UI"/>
+                <a:cs typeface="Segoe UI"/>
               </a:defRPr>
             </a:pPr>
             <a:r>
               <a:rPr sz="2250" b="0">
                 <a:solidFill>
-                  <a:srgbClr val="152F2C"/>
-                </a:solidFill>
-                <a:latin typeface="Arial"/>
-                <a:ea typeface="Arial"/>
-                <a:cs typeface="Arial"/>
+                  <a:srgbClr val="191F28"/>
+                </a:solidFill>
+                <a:latin typeface="Segoe UI"/>
+                <a:ea typeface="Segoe UI"/>
+                <a:cs typeface="Segoe UI"/>
               </a:rPr>
               <a:t>FOR THE RECORD keeps the intention, the result</a:t>
             </a:r>
@@ -2108,21 +2108,21 @@
             <a:pPr>
               <a:defRPr sz="2250" b="0">
                 <a:solidFill>
-                  <a:srgbClr val="152F2C"/>
-                </a:solidFill>
-                <a:latin typeface="Arial"/>
-                <a:ea typeface="Arial"/>
-                <a:cs typeface="Arial"/>
+                  <a:srgbClr val="191F28"/>
+                </a:solidFill>
+                <a:latin typeface="Segoe UI"/>
+                <a:ea typeface="Segoe UI"/>
+                <a:cs typeface="Segoe UI"/>
               </a:defRPr>
             </a:pPr>
             <a:r>
               <a:rPr sz="2250" b="0">
                 <a:solidFill>
-                  <a:srgbClr val="152F2C"/>
-                </a:solidFill>
-                <a:latin typeface="Arial"/>
-                <a:ea typeface="Arial"/>
-                <a:cs typeface="Arial"/>
+                  <a:srgbClr val="191F28"/>
+                </a:solidFill>
+                <a:latin typeface="Segoe UI"/>
+                <a:ea typeface="Segoe UI"/>
+                <a:cs typeface="Segoe UI"/>
               </a:rPr>
               <a:t>and a useful next action together.</a:t>
             </a:r>
@@ -2134,7 +2134,7 @@
           <p:cNvPr id="5" name="">
             <a:extLst xmlns:a="http://schemas.openxmlformats.org/drawingml/2006/main">
               <a:ext uri="{FF2B5EF4-FFF2-40B4-BE49-F238E27FC236}">
-                <a16:creationId xmlns:a16="http://schemas.microsoft.com/office/drawing/2014/main" id="{A3CE931F-4638-41A9-AC02-3C9AEC577A0B}"/>
+                <a16:creationId xmlns:a16="http://schemas.microsoft.com/office/drawing/2014/main" id="{14695DD0-74DE-4904-AD16-51863CDAB2B2}"/>
               </a:ext>
             </a:extLst>
           </p:cNvPr>
@@ -2165,21 +2165,21 @@
             <a:pPr>
               <a:defRPr sz="1500" b="0">
                 <a:solidFill>
-                  <a:srgbClr val="526762"/>
-                </a:solidFill>
-                <a:latin typeface="Arial"/>
-                <a:ea typeface="Arial"/>
-                <a:cs typeface="Arial"/>
+                  <a:srgbClr val="667085"/>
+                </a:solidFill>
+                <a:latin typeface="Segoe UI"/>
+                <a:ea typeface="Segoe UI"/>
+                <a:cs typeface="Segoe UI"/>
               </a:defRPr>
             </a:pPr>
             <a:r>
               <a:rPr sz="1500" b="0">
                 <a:solidFill>
-                  <a:srgbClr val="526762"/>
-                </a:solidFill>
-                <a:latin typeface="Arial"/>
-                <a:ea typeface="Arial"/>
-                <a:cs typeface="Arial"/>
+                  <a:srgbClr val="667085"/>
+                </a:solidFill>
+                <a:latin typeface="Segoe UI"/>
+                <a:ea typeface="Segoe UI"/>
+                <a:cs typeface="Segoe UI"/>
               </a:rPr>
               <a:t>Product hypothesis: a clear next action makes returning easier. Retention is not yet measured.</a:t>
             </a:r>
@@ -2191,7 +2191,7 @@
           <p:cNvPr id="6" name="">
             <a:extLst xmlns:a="http://schemas.openxmlformats.org/drawingml/2006/main">
               <a:ext uri="{FF2B5EF4-FFF2-40B4-BE49-F238E27FC236}">
-                <a16:creationId xmlns:a16="http://schemas.microsoft.com/office/drawing/2014/main" id="{C863FB17-83EF-4114-B742-DE2737CDFC8D}"/>
+                <a16:creationId xmlns:a16="http://schemas.microsoft.com/office/drawing/2014/main" id="{1B010E9E-1B3A-447F-8F70-2837CB7560A6}"/>
               </a:ext>
             </a:extLst>
           </p:cNvPr>
@@ -2222,21 +2222,21 @@
             <a:pPr>
               <a:defRPr sz="1200" b="0">
                 <a:solidFill>
-                  <a:srgbClr val="526762"/>
-                </a:solidFill>
-                <a:latin typeface="Arial"/>
-                <a:ea typeface="Arial"/>
-                <a:cs typeface="Arial"/>
+                  <a:srgbClr val="667085"/>
+                </a:solidFill>
+                <a:latin typeface="Segoe UI"/>
+                <a:ea typeface="Segoe UI"/>
+                <a:cs typeface="Segoe UI"/>
               </a:defRPr>
             </a:pPr>
             <a:r>
               <a:rPr sz="1200" b="0">
                 <a:solidFill>
-                  <a:srgbClr val="526762"/>
-                </a:solidFill>
-                <a:latin typeface="Arial"/>
-                <a:ea typeface="Arial"/>
-                <a:cs typeface="Arial"/>
+                  <a:srgbClr val="667085"/>
+                </a:solidFill>
+                <a:latin typeface="Segoe UI"/>
+                <a:ea typeface="Segoe UI"/>
+                <a:cs typeface="Segoe UI"/>
               </a:rPr>
               <a:t>FOR THE RECORD   /   02</a:t>
             </a:r>
@@ -2246,7 +2246,7 @@
     </p:spTree>
     <p:extLst>
       <p:ext uri="{BB962C8B-B14F-4D97-AF65-F5344CB8AC3E}">
-        <p14:creationId xmlns:p14="http://schemas.microsoft.com/office/powerpoint/2010/main" val="1287623629"/>
+        <p14:creationId xmlns:p14="http://schemas.microsoft.com/office/powerpoint/2010/main" val="1842076148"/>
       </p:ext>
     </p:extLst>
   </p:cSld>
@@ -2259,7 +2259,7 @@
     <p:bg>
       <p:bgPr>
         <a:solidFill xmlns:a="http://schemas.openxmlformats.org/drawingml/2006/main">
-          <a:srgbClr val="F0F5F1"/>
+          <a:srgbClr val="F4F5F7"/>
         </a:solidFill>
       </p:bgPr>
     </p:bg>
@@ -2274,10 +2274,10 @@
       </p:grpSpPr>
       <p:sp>
         <p:nvSpPr>
-          <p:cNvPr id="6" name="">
+          <p:cNvPr id="7" name="">
             <a:extLst xmlns:a="http://schemas.openxmlformats.org/drawingml/2006/main">
               <a:ext uri="{FF2B5EF4-FFF2-40B4-BE49-F238E27FC236}">
-                <a16:creationId xmlns:a16="http://schemas.microsoft.com/office/drawing/2014/main" id="{E5486EE5-2B5F-4851-8146-646000988A61}"/>
+                <a16:creationId xmlns:a16="http://schemas.microsoft.com/office/drawing/2014/main" id="{D366EE54-5E17-4FBF-924F-CCA93DCFECE5}"/>
               </a:ext>
             </a:extLst>
           </p:cNvPr>
@@ -2289,7 +2289,7 @@
         <p:spPr>
           <a:xfrm xmlns:a="http://schemas.openxmlformats.org/drawingml/2006/main">
             <a:off x="685800" y="666750"/>
-            <a:ext cx="7048500" cy="762000"/>
+            <a:ext cx="10858500" cy="762000"/>
           </a:xfrm>
           <a:prstGeom xmlns:a="http://schemas.openxmlformats.org/drawingml/2006/main" prst="rect">
             <a:avLst/>
@@ -2306,25 +2306,25 @@
           <a:lstStyle xmlns:a="http://schemas.openxmlformats.org/drawingml/2006/main"/>
           <a:p xmlns:a="http://schemas.openxmlformats.org/drawingml/2006/main">
             <a:pPr>
-              <a:defRPr sz="4050" b="1">
-                <a:solidFill>
-                  <a:srgbClr val="152F2C"/>
-                </a:solidFill>
-                <a:latin typeface="Arial"/>
-                <a:ea typeface="Arial"/>
-                <a:cs typeface="Arial"/>
-              </a:defRPr>
-            </a:pPr>
-            <a:r>
-              <a:rPr sz="4050" b="1">
-                <a:solidFill>
-                  <a:srgbClr val="152F2C"/>
-                </a:solidFill>
-                <a:latin typeface="Arial"/>
-                <a:ea typeface="Arial"/>
-                <a:cs typeface="Arial"/>
-              </a:rPr>
-              <a:t>A useful first session</a:t>
+              <a:defRPr sz="3825" b="1">
+                <a:solidFill>
+                  <a:srgbClr val="191F28"/>
+                </a:solidFill>
+                <a:latin typeface="Segoe UI"/>
+                <a:ea typeface="Segoe UI"/>
+                <a:cs typeface="Segoe UI"/>
+              </a:defRPr>
+            </a:pPr>
+            <a:r>
+              <a:rPr sz="3825" b="1">
+                <a:solidFill>
+                  <a:srgbClr val="191F28"/>
+                </a:solidFill>
+                <a:latin typeface="Segoe UI"/>
+                <a:ea typeface="Segoe UI"/>
+                <a:cs typeface="Segoe UI"/>
+              </a:rPr>
+              <a:t>Leave tomorrow a starting point</a:t>
             </a:r>
           </a:p>
         </p:txBody>
@@ -2334,7 +2334,7 @@
           <p:cNvPr id="2" name="">
             <a:extLst xmlns:a="http://schemas.openxmlformats.org/drawingml/2006/main">
               <a:ext uri="{FF2B5EF4-FFF2-40B4-BE49-F238E27FC236}">
-                <a16:creationId xmlns:a16="http://schemas.microsoft.com/office/drawing/2014/main" id="{99F65BF8-07EE-4B31-AA08-A84C723BA7E2}"/>
+                <a16:creationId xmlns:a16="http://schemas.microsoft.com/office/drawing/2014/main" id="{C300DCBC-B865-40B8-864D-B94DBBE3FEAD}"/>
               </a:ext>
             </a:extLst>
           </p:cNvPr>
@@ -2345,8 +2345,8 @@
         </p:nvSpPr>
         <p:spPr>
           <a:xfrm xmlns:a="http://schemas.openxmlformats.org/drawingml/2006/main">
-            <a:off x="685800" y="1885950"/>
-            <a:ext cx="6572250" cy="2381250"/>
+            <a:off x="685800" y="2095500"/>
+            <a:ext cx="5905500" cy="1638300"/>
           </a:xfrm>
           <a:prstGeom xmlns:a="http://schemas.openxmlformats.org/drawingml/2006/main" prst="rect">
             <a:avLst/>
@@ -2365,92 +2365,69 @@
             <a:pPr>
               <a:defRPr sz="2550" b="0">
                 <a:solidFill>
-                  <a:srgbClr val="152F2C"/>
-                </a:solidFill>
-                <a:latin typeface="Arial"/>
-                <a:ea typeface="Arial"/>
-                <a:cs typeface="Arial"/>
+                  <a:srgbClr val="191F28"/>
+                </a:solidFill>
+                <a:latin typeface="Segoe UI"/>
+                <a:ea typeface="Segoe UI"/>
+                <a:cs typeface="Segoe UI"/>
               </a:defRPr>
             </a:pPr>
             <a:r>
               <a:rPr sz="2550" b="0">
                 <a:solidFill>
-                  <a:srgbClr val="152F2C"/>
-                </a:solidFill>
-                <a:latin typeface="Arial"/>
-                <a:ea typeface="Arial"/>
-                <a:cs typeface="Arial"/>
-              </a:rPr>
-              <a:t>Create a project.</a:t>
+                  <a:srgbClr val="191F28"/>
+                </a:solidFill>
+                <a:latin typeface="Segoe UI"/>
+                <a:ea typeface="Segoe UI"/>
+                <a:cs typeface="Segoe UI"/>
+              </a:rPr>
+              <a:t>Set an intention.</a:t>
             </a:r>
           </a:p>
           <a:p xmlns:a="http://schemas.openxmlformats.org/drawingml/2006/main">
             <a:pPr>
               <a:defRPr sz="2550" b="0">
                 <a:solidFill>
-                  <a:srgbClr val="152F2C"/>
-                </a:solidFill>
-                <a:latin typeface="Arial"/>
-                <a:ea typeface="Arial"/>
-                <a:cs typeface="Arial"/>
+                  <a:srgbClr val="191F28"/>
+                </a:solidFill>
+                <a:latin typeface="Segoe UI"/>
+                <a:ea typeface="Segoe UI"/>
+                <a:cs typeface="Segoe UI"/>
               </a:defRPr>
             </a:pPr>
             <a:r>
               <a:rPr sz="2550" b="0">
                 <a:solidFill>
-                  <a:srgbClr val="152F2C"/>
-                </a:solidFill>
-                <a:latin typeface="Arial"/>
-                <a:ea typeface="Arial"/>
-                <a:cs typeface="Arial"/>
-              </a:rPr>
-              <a:t>Write one intention.</a:t>
+                  <a:srgbClr val="191F28"/>
+                </a:solidFill>
+                <a:latin typeface="Segoe UI"/>
+                <a:ea typeface="Segoe UI"/>
+                <a:cs typeface="Segoe UI"/>
+              </a:rPr>
+              <a:t>Do the work.</a:t>
             </a:r>
           </a:p>
           <a:p xmlns:a="http://schemas.openxmlformats.org/drawingml/2006/main">
             <a:pPr>
               <a:defRPr sz="2550" b="0">
                 <a:solidFill>
-                  <a:srgbClr val="152F2C"/>
-                </a:solidFill>
-                <a:latin typeface="Arial"/>
-                <a:ea typeface="Arial"/>
-                <a:cs typeface="Arial"/>
+                  <a:srgbClr val="191F28"/>
+                </a:solidFill>
+                <a:latin typeface="Segoe UI"/>
+                <a:ea typeface="Segoe UI"/>
+                <a:cs typeface="Segoe UI"/>
               </a:defRPr>
             </a:pPr>
             <a:r>
               <a:rPr sz="2550" b="0">
                 <a:solidFill>
-                  <a:srgbClr val="152F2C"/>
-                </a:solidFill>
-                <a:latin typeface="Arial"/>
-                <a:ea typeface="Arial"/>
-                <a:cs typeface="Arial"/>
-              </a:rPr>
-              <a:t>Choose a focus duration.</a:t>
-            </a:r>
-          </a:p>
-          <a:p xmlns:a="http://schemas.openxmlformats.org/drawingml/2006/main">
-            <a:pPr>
-              <a:defRPr sz="2550" b="0">
-                <a:solidFill>
-                  <a:srgbClr val="152F2C"/>
-                </a:solidFill>
-                <a:latin typeface="Arial"/>
-                <a:ea typeface="Arial"/>
-                <a:cs typeface="Arial"/>
-              </a:defRPr>
-            </a:pPr>
-            <a:r>
-              <a:rPr sz="2550" b="0">
-                <a:solidFill>
-                  <a:srgbClr val="152F2C"/>
-                </a:solidFill>
-                <a:latin typeface="Arial"/>
-                <a:ea typeface="Arial"/>
-                <a:cs typeface="Arial"/>
-              </a:rPr>
-              <a:t>Save the result and next action.</a:t>
+                  <a:srgbClr val="191F28"/>
+                </a:solidFill>
+                <a:latin typeface="Segoe UI"/>
+                <a:ea typeface="Segoe UI"/>
+                <a:cs typeface="Segoe UI"/>
+              </a:rPr>
+              <a:t>Save one next action.</a:t>
             </a:r>
           </a:p>
         </p:txBody>
@@ -2460,7 +2437,7 @@
           <p:cNvPr id="3" name="">
             <a:extLst xmlns:a="http://schemas.openxmlformats.org/drawingml/2006/main">
               <a:ext uri="{FF2B5EF4-FFF2-40B4-BE49-F238E27FC236}">
-                <a16:creationId xmlns:a16="http://schemas.microsoft.com/office/drawing/2014/main" id="{6CE3A9CE-449A-4A1B-8894-CCBF42AC1EBD}"/>
+                <a16:creationId xmlns:a16="http://schemas.microsoft.com/office/drawing/2014/main" id="{2B9A749F-2F6D-4E2F-BDA6-2371AF5B4819}"/>
               </a:ext>
             </a:extLst>
           </p:cNvPr>
@@ -2471,8 +2448,8 @@
         </p:nvSpPr>
         <p:spPr>
           <a:xfrm xmlns:a="http://schemas.openxmlformats.org/drawingml/2006/main">
-            <a:off x="685800" y="4714875"/>
-            <a:ext cx="6238875" cy="857250"/>
+            <a:off x="685800" y="4200525"/>
+            <a:ext cx="5810250" cy="1047750"/>
           </a:xfrm>
           <a:prstGeom xmlns:a="http://schemas.openxmlformats.org/drawingml/2006/main" prst="rect">
             <a:avLst/>
@@ -2489,68 +2466,68 @@
           <a:lstStyle xmlns:a="http://schemas.openxmlformats.org/drawingml/2006/main"/>
           <a:p xmlns:a="http://schemas.openxmlformats.org/drawingml/2006/main">
             <a:pPr>
-              <a:defRPr sz="2250" b="1">
-                <a:solidFill>
-                  <a:srgbClr val="096B61"/>
-                </a:solidFill>
-                <a:latin typeface="Arial"/>
-                <a:ea typeface="Arial"/>
-                <a:cs typeface="Arial"/>
-              </a:defRPr>
-            </a:pPr>
-            <a:r>
-              <a:rPr sz="2250" b="1">
-                <a:solidFill>
-                  <a:srgbClr val="096B61"/>
-                </a:solidFill>
-                <a:latin typeface="Arial"/>
-                <a:ea typeface="Arial"/>
-                <a:cs typeface="Arial"/>
-              </a:rPr>
-              <a:t>Core journaling works offline</a:t>
-            </a:r>
-          </a:p>
-          <a:p xmlns:a="http://schemas.openxmlformats.org/drawingml/2006/main">
-            <a:pPr>
-              <a:defRPr sz="2250" b="1">
-                <a:solidFill>
-                  <a:srgbClr val="096B61"/>
-                </a:solidFill>
-                <a:latin typeface="Arial"/>
-                <a:ea typeface="Arial"/>
-                <a:cs typeface="Arial"/>
-              </a:defRPr>
-            </a:pPr>
-            <a:r>
-              <a:rPr sz="2250" b="1">
-                <a:solidFill>
-                  <a:srgbClr val="096B61"/>
-                </a:solidFill>
-                <a:latin typeface="Arial"/>
-                <a:ea typeface="Arial"/>
-                <a:cs typeface="Arial"/>
-              </a:rPr>
-              <a:t>without an account or wallet.</a:t>
+              <a:defRPr sz="2550" b="1">
+                <a:solidFill>
+                  <a:srgbClr val="007F78"/>
+                </a:solidFill>
+                <a:latin typeface="Segoe UI"/>
+                <a:ea typeface="Segoe UI"/>
+                <a:cs typeface="Segoe UI"/>
+              </a:defRPr>
+            </a:pPr>
+            <a:r>
+              <a:rPr sz="2550" b="1">
+                <a:solidFill>
+                  <a:srgbClr val="007F78"/>
+                </a:solidFill>
+                <a:latin typeface="Segoe UI"/>
+                <a:ea typeface="Segoe UI"/>
+                <a:cs typeface="Segoe UI"/>
+              </a:rPr>
+              <a:t>Return to your own words,</a:t>
+            </a:r>
+          </a:p>
+          <a:p xmlns:a="http://schemas.openxmlformats.org/drawingml/2006/main">
+            <a:pPr>
+              <a:defRPr sz="2550" b="1">
+                <a:solidFill>
+                  <a:srgbClr val="007F78"/>
+                </a:solidFill>
+                <a:latin typeface="Segoe UI"/>
+                <a:ea typeface="Segoe UI"/>
+                <a:cs typeface="Segoe UI"/>
+              </a:defRPr>
+            </a:pPr>
+            <a:r>
+              <a:rPr sz="2550" b="1">
+                <a:solidFill>
+                  <a:srgbClr val="007F78"/>
+                </a:solidFill>
+                <a:latin typeface="Segoe UI"/>
+                <a:ea typeface="Segoe UI"/>
+                <a:cs typeface="Segoe UI"/>
+              </a:rPr>
+              <a:t>already filled in.</a:t>
             </a:r>
           </a:p>
         </p:txBody>
       </p:sp>
       <p:pic>
         <p:nvPicPr>
-          <p:cNvPr id="9" name=""/>
+          <p:cNvPr id="10" name=""/>
           <p:cNvPicPr>
             <a:picLocks xmlns:a="http://schemas.openxmlformats.org/drawingml/2006/main" noChangeAspect="1"/>
           </p:cNvPicPr>
           <p:nvPr/>
         </p:nvPicPr>
         <p:blipFill>
-          <a:blip xmlns:r="http://schemas.openxmlformats.org/officeDocument/2006/relationships" xmlns:a="http://schemas.openxmlformats.org/drawingml/2006/main" r:embed="R022296f361874690"/>
+          <a:blip xmlns:r="http://schemas.openxmlformats.org/officeDocument/2006/relationships" xmlns:a="http://schemas.openxmlformats.org/drawingml/2006/main" r:embed="R8f3383d29d16457d"/>
           <a:stretch xmlns:a="http://schemas.openxmlformats.org/drawingml/2006/main"/>
         </p:blipFill>
         <p:spPr>
           <a:xfrm xmlns:a="http://schemas.openxmlformats.org/drawingml/2006/main">
-            <a:off x="8366284" y="400050"/>
-            <a:ext cx="2546033" cy="5657850"/>
+            <a:off x="6877050" y="2107406"/>
+            <a:ext cx="4667250" cy="3500438"/>
           </a:xfrm>
           <a:prstGeom xmlns:a="http://schemas.openxmlformats.org/drawingml/2006/main" prst="rect">
             <a:avLst/>
@@ -2562,7 +2539,64 @@
           <p:cNvPr id="5" name="">
             <a:extLst xmlns:a="http://schemas.openxmlformats.org/drawingml/2006/main">
               <a:ext uri="{FF2B5EF4-FFF2-40B4-BE49-F238E27FC236}">
-                <a16:creationId xmlns:a16="http://schemas.microsoft.com/office/drawing/2014/main" id="{BD20E8A8-38E6-48DB-8C91-5AE748E7EAAB}"/>
+                <a16:creationId xmlns:a16="http://schemas.microsoft.com/office/drawing/2014/main" id="{D2F04EDD-FA88-4E82-976F-7BDBCC045D11}"/>
+              </a:ext>
+            </a:extLst>
+          </p:cNvPr>
+          <p:cNvSpPr>
+            <a:spLocks xmlns:a="http://schemas.openxmlformats.org/drawingml/2006/main" noGrp="1"/>
+          </p:cNvSpPr>
+          <p:nvPr/>
+        </p:nvSpPr>
+        <p:spPr>
+          <a:xfrm xmlns:a="http://schemas.openxmlformats.org/drawingml/2006/main">
+            <a:off x="7048500" y="5905500"/>
+            <a:ext cx="4429125" cy="257175"/>
+          </a:xfrm>
+          <a:prstGeom xmlns:a="http://schemas.openxmlformats.org/drawingml/2006/main" prst="rect">
+            <a:avLst/>
+          </a:prstGeom>
+          <a:noFill xmlns:a="http://schemas.openxmlformats.org/drawingml/2006/main"/>
+          <a:ln xmlns:a="http://schemas.openxmlformats.org/drawingml/2006/main" w="0">
+            <a:noFill/>
+          </a:ln>
+        </p:spPr>
+        <p:txBody>
+          <a:bodyPr xmlns:a="http://schemas.openxmlformats.org/drawingml/2006/main">
+            <a:noAutofit/>
+          </a:bodyPr>
+          <a:lstStyle xmlns:a="http://schemas.openxmlformats.org/drawingml/2006/main"/>
+          <a:p xmlns:a="http://schemas.openxmlformats.org/drawingml/2006/main">
+            <a:pPr>
+              <a:defRPr sz="1125" b="1">
+                <a:solidFill>
+                  <a:srgbClr val="667085"/>
+                </a:solidFill>
+                <a:latin typeface="Segoe UI"/>
+                <a:ea typeface="Segoe UI"/>
+                <a:cs typeface="Segoe UI"/>
+              </a:defRPr>
+            </a:pPr>
+            <a:r>
+              <a:rPr sz="1125" b="1">
+                <a:solidFill>
+                  <a:srgbClr val="667085"/>
+                </a:solidFill>
+                <a:latin typeface="Segoe UI"/>
+                <a:ea typeface="Segoe UI"/>
+                <a:cs typeface="Segoe UI"/>
+              </a:rPr>
+              <a:t>ACTUAL ANDROID DEMO  /  SAVED NEXT ACTION</a:t>
+            </a:r>
+          </a:p>
+        </p:txBody>
+      </p:sp>
+      <p:sp>
+        <p:nvSpPr>
+          <p:cNvPr id="6" name="">
+            <a:extLst xmlns:a="http://schemas.openxmlformats.org/drawingml/2006/main">
+              <a:ext uri="{FF2B5EF4-FFF2-40B4-BE49-F238E27FC236}">
+                <a16:creationId xmlns:a16="http://schemas.microsoft.com/office/drawing/2014/main" id="{8E200C68-A765-4368-8728-BA172FAAE366}"/>
               </a:ext>
             </a:extLst>
           </p:cNvPr>
@@ -2593,21 +2627,21 @@
             <a:pPr>
               <a:defRPr sz="1200" b="0">
                 <a:solidFill>
-                  <a:srgbClr val="526762"/>
-                </a:solidFill>
-                <a:latin typeface="Arial"/>
-                <a:ea typeface="Arial"/>
-                <a:cs typeface="Arial"/>
+                  <a:srgbClr val="667085"/>
+                </a:solidFill>
+                <a:latin typeface="Segoe UI"/>
+                <a:ea typeface="Segoe UI"/>
+                <a:cs typeface="Segoe UI"/>
               </a:defRPr>
             </a:pPr>
             <a:r>
               <a:rPr sz="1200" b="0">
                 <a:solidFill>
-                  <a:srgbClr val="526762"/>
-                </a:solidFill>
-                <a:latin typeface="Arial"/>
-                <a:ea typeface="Arial"/>
-                <a:cs typeface="Arial"/>
+                  <a:srgbClr val="667085"/>
+                </a:solidFill>
+                <a:latin typeface="Segoe UI"/>
+                <a:ea typeface="Segoe UI"/>
+                <a:cs typeface="Segoe UI"/>
               </a:rPr>
               <a:t>FOR THE RECORD   /   03</a:t>
             </a:r>
@@ -2617,7 +2651,7 @@
     </p:spTree>
     <p:extLst>
       <p:ext uri="{BB962C8B-B14F-4D97-AF65-F5344CB8AC3E}">
-        <p14:creationId xmlns:p14="http://schemas.microsoft.com/office/powerpoint/2010/main" val="454533705"/>
+        <p14:creationId xmlns:p14="http://schemas.microsoft.com/office/powerpoint/2010/main" val="127440215"/>
       </p:ext>
     </p:extLst>
   </p:cSld>
@@ -2630,7 +2664,7 @@
     <p:bg>
       <p:bgPr>
         <a:solidFill xmlns:a="http://schemas.openxmlformats.org/drawingml/2006/main">
-          <a:srgbClr val="096B61"/>
+          <a:srgbClr val="191F28"/>
         </a:solidFill>
       </p:bgPr>
     </p:bg>
@@ -2645,10 +2679,10 @@
       </p:grpSpPr>
       <p:sp>
         <p:nvSpPr>
-          <p:cNvPr id="7" name="">
+          <p:cNvPr id="8" name="">
             <a:extLst xmlns:a="http://schemas.openxmlformats.org/drawingml/2006/main">
               <a:ext uri="{FF2B5EF4-FFF2-40B4-BE49-F238E27FC236}">
-                <a16:creationId xmlns:a16="http://schemas.microsoft.com/office/drawing/2014/main" id="{80729BC7-9412-42A7-B290-1AB7EE1FC50D}"/>
+                <a16:creationId xmlns:a16="http://schemas.microsoft.com/office/drawing/2014/main" id="{B89BF484-BD22-407A-A93D-3AEC3808D6EA}"/>
               </a:ext>
             </a:extLst>
           </p:cNvPr>
@@ -2660,7 +2694,7 @@
         <p:spPr>
           <a:xfrm xmlns:a="http://schemas.openxmlformats.org/drawingml/2006/main">
             <a:off x="685800" y="666750"/>
-            <a:ext cx="10668000" cy="742950"/>
+            <a:ext cx="10858500" cy="742950"/>
           </a:xfrm>
           <a:prstGeom xmlns:a="http://schemas.openxmlformats.org/drawingml/2006/main" prst="rect">
             <a:avLst/>
@@ -2677,25 +2711,25 @@
           <a:lstStyle xmlns:a="http://schemas.openxmlformats.org/drawingml/2006/main"/>
           <a:p xmlns:a="http://schemas.openxmlformats.org/drawingml/2006/main">
             <a:pPr>
-              <a:defRPr sz="3825" b="1">
-                <a:solidFill>
-                  <a:srgbClr val="F2FFCE"/>
-                </a:solidFill>
-                <a:latin typeface="Arial"/>
-                <a:ea typeface="Arial"/>
-                <a:cs typeface="Arial"/>
-              </a:defRPr>
-            </a:pPr>
-            <a:r>
-              <a:rPr sz="3825" b="1">
-                <a:solidFill>
-                  <a:srgbClr val="F2FFCE"/>
-                </a:solidFill>
-                <a:latin typeface="Arial"/>
-                <a:ea typeface="Arial"/>
-                <a:cs typeface="Arial"/>
-              </a:rPr>
-              <a:t>Context for a wallet decision</a:t>
+              <a:defRPr sz="3675" b="1">
+                <a:solidFill>
+                  <a:srgbClr val="FFFFFF"/>
+                </a:solidFill>
+                <a:latin typeface="Segoe UI"/>
+                <a:ea typeface="Segoe UI"/>
+                <a:cs typeface="Segoe UI"/>
+              </a:defRPr>
+            </a:pPr>
+            <a:r>
+              <a:rPr sz="3675" b="1">
+                <a:solidFill>
+                  <a:srgbClr val="FFFFFF"/>
+                </a:solidFill>
+                <a:latin typeface="Segoe UI"/>
+                <a:ea typeface="Segoe UI"/>
+                <a:cs typeface="Segoe UI"/>
+              </a:rPr>
+              <a:t>Keep the reason. Return with context.</a:t>
             </a:r>
           </a:p>
         </p:txBody>
@@ -2705,7 +2739,7 @@
           <p:cNvPr id="2" name="">
             <a:extLst xmlns:a="http://schemas.openxmlformats.org/drawingml/2006/main">
               <a:ext uri="{FF2B5EF4-FFF2-40B4-BE49-F238E27FC236}">
-                <a16:creationId xmlns:a16="http://schemas.microsoft.com/office/drawing/2014/main" id="{E22106C1-D7AD-4541-9CEE-BFEA067EB40A}"/>
+                <a16:creationId xmlns:a16="http://schemas.microsoft.com/office/drawing/2014/main" id="{F96DD547-A4FE-444C-B55A-76A0E2F3180A}"/>
               </a:ext>
             </a:extLst>
           </p:cNvPr>
@@ -2716,8 +2750,8 @@
         </p:nvSpPr>
         <p:spPr>
           <a:xfrm xmlns:a="http://schemas.openxmlformats.org/drawingml/2006/main">
-            <a:off x="685800" y="1952625"/>
-            <a:ext cx="4476750" cy="2533650"/>
+            <a:off x="685800" y="2200275"/>
+            <a:ext cx="5238750" cy="1714500"/>
           </a:xfrm>
           <a:prstGeom xmlns:a="http://schemas.openxmlformats.org/drawingml/2006/main" prst="rect">
             <a:avLst/>
@@ -2734,94 +2768,71 @@
           <a:lstStyle xmlns:a="http://schemas.openxmlformats.org/drawingml/2006/main"/>
           <a:p xmlns:a="http://schemas.openxmlformats.org/drawingml/2006/main">
             <a:pPr>
-              <a:defRPr sz="3300" b="1">
-                <a:solidFill>
-                  <a:srgbClr val="FFFEFA"/>
-                </a:solidFill>
-                <a:latin typeface="Arial"/>
-                <a:ea typeface="Arial"/>
-                <a:cs typeface="Arial"/>
-              </a:defRPr>
-            </a:pPr>
-            <a:r>
-              <a:rPr sz="3300" b="1">
-                <a:solidFill>
-                  <a:srgbClr val="FFFEFA"/>
-                </a:solidFill>
-                <a:latin typeface="Arial"/>
-                <a:ea typeface="Arial"/>
-                <a:cs typeface="Arial"/>
-              </a:rPr>
-              <a:t>Reason</a:t>
-            </a:r>
-          </a:p>
-          <a:p xmlns:a="http://schemas.openxmlformats.org/drawingml/2006/main">
-            <a:pPr>
-              <a:defRPr sz="3300" b="1">
-                <a:solidFill>
-                  <a:srgbClr val="FFFEFA"/>
-                </a:solidFill>
-                <a:latin typeface="Arial"/>
-                <a:ea typeface="Arial"/>
-                <a:cs typeface="Arial"/>
-              </a:defRPr>
-            </a:pPr>
-            <a:r>
-              <a:rPr sz="3300" b="1">
-                <a:solidFill>
-                  <a:srgbClr val="FFFEFA"/>
-                </a:solidFill>
-                <a:latin typeface="Arial"/>
-                <a:ea typeface="Arial"/>
-                <a:cs typeface="Arial"/>
-              </a:rPr>
-              <a:t>Plan</a:t>
-            </a:r>
-          </a:p>
-          <a:p xmlns:a="http://schemas.openxmlformats.org/drawingml/2006/main">
-            <a:pPr>
-              <a:defRPr sz="3300" b="1">
-                <a:solidFill>
-                  <a:srgbClr val="FFFEFA"/>
-                </a:solidFill>
-                <a:latin typeface="Arial"/>
-                <a:ea typeface="Arial"/>
-                <a:cs typeface="Arial"/>
-              </a:defRPr>
-            </a:pPr>
-            <a:r>
-              <a:rPr sz="3300" b="1">
-                <a:solidFill>
-                  <a:srgbClr val="FFFEFA"/>
-                </a:solidFill>
-                <a:latin typeface="Arial"/>
-                <a:ea typeface="Arial"/>
-                <a:cs typeface="Arial"/>
-              </a:rPr>
-              <a:t>Emotion</a:t>
-            </a:r>
-          </a:p>
-          <a:p xmlns:a="http://schemas.openxmlformats.org/drawingml/2006/main">
-            <a:pPr>
-              <a:defRPr sz="3300" b="1">
-                <a:solidFill>
-                  <a:srgbClr val="FFFEFA"/>
-                </a:solidFill>
-                <a:latin typeface="Arial"/>
-                <a:ea typeface="Arial"/>
-                <a:cs typeface="Arial"/>
-              </a:defRPr>
-            </a:pPr>
-            <a:r>
-              <a:rPr sz="3300" b="1">
-                <a:solidFill>
-                  <a:srgbClr val="FFFEFA"/>
-                </a:solidFill>
-                <a:latin typeface="Arial"/>
-                <a:ea typeface="Arial"/>
-                <a:cs typeface="Arial"/>
-              </a:rPr>
-              <a:t>Next action</a:t>
+              <a:defRPr sz="2400" b="0">
+                <a:solidFill>
+                  <a:srgbClr val="FFFFFF"/>
+                </a:solidFill>
+                <a:latin typeface="Segoe UI"/>
+                <a:ea typeface="Segoe UI"/>
+                <a:cs typeface="Segoe UI"/>
+              </a:defRPr>
+            </a:pPr>
+            <a:r>
+              <a:rPr sz="2400" b="0">
+                <a:solidFill>
+                  <a:srgbClr val="FFFFFF"/>
+                </a:solidFill>
+                <a:latin typeface="Segoe UI"/>
+                <a:ea typeface="Segoe UI"/>
+                <a:cs typeface="Segoe UI"/>
+              </a:rPr>
+              <a:t>A saved reflection keeps</a:t>
+            </a:r>
+          </a:p>
+          <a:p xmlns:a="http://schemas.openxmlformats.org/drawingml/2006/main">
+            <a:pPr>
+              <a:defRPr sz="2400" b="0">
+                <a:solidFill>
+                  <a:srgbClr val="FFFFFF"/>
+                </a:solidFill>
+                <a:latin typeface="Segoe UI"/>
+                <a:ea typeface="Segoe UI"/>
+                <a:cs typeface="Segoe UI"/>
+              </a:defRPr>
+            </a:pPr>
+            <a:r>
+              <a:rPr sz="2400" b="0">
+                <a:solidFill>
+                  <a:srgbClr val="FFFFFF"/>
+                </a:solidFill>
+                <a:latin typeface="Segoe UI"/>
+                <a:ea typeface="Segoe UI"/>
+                <a:cs typeface="Segoe UI"/>
+              </a:rPr>
+              <a:t>your reason and original plan</a:t>
+            </a:r>
+          </a:p>
+          <a:p xmlns:a="http://schemas.openxmlformats.org/drawingml/2006/main">
+            <a:pPr>
+              <a:defRPr sz="2400" b="0">
+                <a:solidFill>
+                  <a:srgbClr val="FFFFFF"/>
+                </a:solidFill>
+                <a:latin typeface="Segoe UI"/>
+                <a:ea typeface="Segoe UI"/>
+                <a:cs typeface="Segoe UI"/>
+              </a:defRPr>
+            </a:pPr>
+            <a:r>
+              <a:rPr sz="2400" b="0">
+                <a:solidFill>
+                  <a:srgbClr val="FFFFFF"/>
+                </a:solidFill>
+                <a:latin typeface="Segoe UI"/>
+                <a:ea typeface="Segoe UI"/>
+                <a:cs typeface="Segoe UI"/>
+              </a:rPr>
+              <a:t>close to the event.</a:t>
             </a:r>
           </a:p>
         </p:txBody>
@@ -2831,7 +2842,7 @@
           <p:cNvPr id="3" name="">
             <a:extLst xmlns:a="http://schemas.openxmlformats.org/drawingml/2006/main">
               <a:ext uri="{FF2B5EF4-FFF2-40B4-BE49-F238E27FC236}">
-                <a16:creationId xmlns:a16="http://schemas.microsoft.com/office/drawing/2014/main" id="{8596EF83-9FDF-4437-ADBF-404BCE1CE1A8}"/>
+                <a16:creationId xmlns:a16="http://schemas.microsoft.com/office/drawing/2014/main" id="{470FA950-A3C8-43AC-951E-D3E5B003EAD3}"/>
               </a:ext>
             </a:extLst>
           </p:cNvPr>
@@ -2842,8 +2853,8 @@
         </p:nvSpPr>
         <p:spPr>
           <a:xfrm xmlns:a="http://schemas.openxmlformats.org/drawingml/2006/main">
-            <a:off x="5600700" y="2028825"/>
-            <a:ext cx="5753100" cy="1238250"/>
+            <a:off x="685800" y="4333875"/>
+            <a:ext cx="5143500" cy="952500"/>
           </a:xfrm>
           <a:prstGeom xmlns:a="http://schemas.openxmlformats.org/drawingml/2006/main" prst="rect">
             <a:avLst/>
@@ -2860,48 +2871,48 @@
           <a:lstStyle xmlns:a="http://schemas.openxmlformats.org/drawingml/2006/main"/>
           <a:p xmlns:a="http://schemas.openxmlformats.org/drawingml/2006/main">
             <a:pPr>
-              <a:defRPr sz="2175" b="0">
-                <a:solidFill>
-                  <a:srgbClr val="FFFEFA"/>
-                </a:solidFill>
-                <a:latin typeface="Arial"/>
-                <a:ea typeface="Arial"/>
-                <a:cs typeface="Arial"/>
-              </a:defRPr>
-            </a:pPr>
-            <a:r>
-              <a:rPr sz="2175" b="0">
-                <a:solidFill>
-                  <a:srgbClr val="FFFEFA"/>
-                </a:solidFill>
-                <a:latin typeface="Arial"/>
-                <a:ea typeface="Arial"/>
-                <a:cs typeface="Arial"/>
-              </a:rPr>
-              <a:t>Supported wallet activity anchors a private reflection.</a:t>
-            </a:r>
-          </a:p>
-          <a:p xmlns:a="http://schemas.openxmlformats.org/drawingml/2006/main">
-            <a:pPr>
-              <a:defRPr sz="2175" b="0">
-                <a:solidFill>
-                  <a:srgbClr val="FFFEFA"/>
-                </a:solidFill>
-                <a:latin typeface="Arial"/>
-                <a:ea typeface="Arial"/>
-                <a:cs typeface="Arial"/>
-              </a:defRPr>
-            </a:pPr>
-            <a:r>
-              <a:rPr sz="2175" b="0">
-                <a:solidFill>
-                  <a:srgbClr val="FFFEFA"/>
-                </a:solidFill>
-                <a:latin typeface="Arial"/>
-                <a:ea typeface="Arial"/>
-                <a:cs typeface="Arial"/>
-              </a:rPr>
-              <a:t>Chain facts stay separate from editable writing.</a:t>
+              <a:defRPr sz="2400" b="1">
+                <a:solidFill>
+                  <a:srgbClr val="D5F56B"/>
+                </a:solidFill>
+                <a:latin typeface="Segoe UI"/>
+                <a:ea typeface="Segoe UI"/>
+                <a:cs typeface="Segoe UI"/>
+              </a:defRPr>
+            </a:pPr>
+            <a:r>
+              <a:rPr sz="2400" b="1">
+                <a:solidFill>
+                  <a:srgbClr val="D5F56B"/>
+                </a:solidFill>
+                <a:latin typeface="Segoe UI"/>
+                <a:ea typeface="Segoe UI"/>
+                <a:cs typeface="Segoe UI"/>
+              </a:rPr>
+              <a:t>Reopen it later.</a:t>
+            </a:r>
+          </a:p>
+          <a:p xmlns:a="http://schemas.openxmlformats.org/drawingml/2006/main">
+            <a:pPr>
+              <a:defRPr sz="2400" b="1">
+                <a:solidFill>
+                  <a:srgbClr val="D5F56B"/>
+                </a:solidFill>
+                <a:latin typeface="Segoe UI"/>
+                <a:ea typeface="Segoe UI"/>
+                <a:cs typeface="Segoe UI"/>
+              </a:defRPr>
+            </a:pPr>
+            <a:r>
+              <a:rPr sz="2400" b="1">
+                <a:solidFill>
+                  <a:srgbClr val="D5F56B"/>
+                </a:solidFill>
+                <a:latin typeface="Segoe UI"/>
+                <a:ea typeface="Segoe UI"/>
+                <a:cs typeface="Segoe UI"/>
+              </a:rPr>
+              <a:t>Add what you learned.</a:t>
             </a:r>
           </a:p>
         </p:txBody>
@@ -2911,7 +2922,7 @@
           <p:cNvPr id="4" name="">
             <a:extLst xmlns:a="http://schemas.openxmlformats.org/drawingml/2006/main">
               <a:ext uri="{FF2B5EF4-FFF2-40B4-BE49-F238E27FC236}">
-                <a16:creationId xmlns:a16="http://schemas.microsoft.com/office/drawing/2014/main" id="{5FB4DA62-3873-469D-A9B5-5666878DD45C}"/>
+                <a16:creationId xmlns:a16="http://schemas.microsoft.com/office/drawing/2014/main" id="{9004E51F-5A09-4636-A853-E95EF4A9EC2E}"/>
               </a:ext>
             </a:extLst>
           </p:cNvPr>
@@ -2922,8 +2933,8 @@
         </p:nvSpPr>
         <p:spPr>
           <a:xfrm xmlns:a="http://schemas.openxmlformats.org/drawingml/2006/main">
-            <a:off x="5600700" y="3771900"/>
-            <a:ext cx="5619750" cy="952500"/>
+            <a:off x="6191250" y="1695450"/>
+            <a:ext cx="5238750" cy="314325"/>
           </a:xfrm>
           <a:prstGeom xmlns:a="http://schemas.openxmlformats.org/drawingml/2006/main" prst="rect">
             <a:avLst/>
@@ -2940,58 +2951,57 @@
           <a:lstStyle xmlns:a="http://schemas.openxmlformats.org/drawingml/2006/main"/>
           <a:p xmlns:a="http://schemas.openxmlformats.org/drawingml/2006/main">
             <a:pPr>
-              <a:defRPr sz="2100" b="0">
-                <a:solidFill>
-                  <a:srgbClr val="FFFEFA"/>
-                </a:solidFill>
-                <a:latin typeface="Arial"/>
-                <a:ea typeface="Arial"/>
-                <a:cs typeface="Arial"/>
-              </a:defRPr>
-            </a:pPr>
-            <a:r>
-              <a:rPr sz="2100" b="0">
-                <a:solidFill>
-                  <a:srgbClr val="FFFEFA"/>
-                </a:solidFill>
-                <a:latin typeface="Arial"/>
-                <a:ea typeface="Arial"/>
-                <a:cs typeface="Arial"/>
-              </a:rPr>
-              <a:t>Native MWA selects the wallet.</a:t>
-            </a:r>
-          </a:p>
-          <a:p xmlns:a="http://schemas.openxmlformats.org/drawingml/2006/main">
-            <a:pPr>
-              <a:defRPr sz="2100" b="0">
-                <a:solidFill>
-                  <a:srgbClr val="FFFEFA"/>
-                </a:solidFill>
-                <a:latin typeface="Arial"/>
-                <a:ea typeface="Arial"/>
-                <a:cs typeface="Arial"/>
-              </a:defRPr>
-            </a:pPr>
-            <a:r>
-              <a:rPr sz="2100" b="0">
-                <a:solidFill>
-                  <a:srgbClr val="FFFEFA"/>
-                </a:solidFill>
-                <a:latin typeface="Arial"/>
-                <a:ea typeface="Arial"/>
-                <a:cs typeface="Arial"/>
-              </a:rPr>
-              <a:t>The app reads public Solana activity.</a:t>
-            </a:r>
-          </a:p>
-        </p:txBody>
-      </p:sp>
-      <p:sp>
-        <p:nvSpPr>
-          <p:cNvPr id="5" name="">
+              <a:defRPr sz="1650" b="1">
+                <a:solidFill>
+                  <a:srgbClr val="FF6B4A"/>
+                </a:solidFill>
+                <a:latin typeface="Segoe UI"/>
+                <a:ea typeface="Segoe UI"/>
+                <a:cs typeface="Segoe UI"/>
+              </a:defRPr>
+            </a:pPr>
+            <a:r>
+              <a:rPr sz="1650" b="1">
+                <a:solidFill>
+                  <a:srgbClr val="FF6B4A"/>
+                </a:solidFill>
+                <a:latin typeface="Segoe UI"/>
+                <a:ea typeface="Segoe UI"/>
+                <a:cs typeface="Segoe UI"/>
+              </a:rPr>
+              <a:t>SAMPLE DATA  /  RECORDED APP</a:t>
+            </a:r>
+          </a:p>
+        </p:txBody>
+      </p:sp>
+      <p:pic>
+        <p:nvPicPr>
+          <p:cNvPr id="12" name=""/>
+          <p:cNvPicPr>
+            <a:picLocks xmlns:a="http://schemas.openxmlformats.org/drawingml/2006/main" noChangeAspect="1"/>
+          </p:cNvPicPr>
+          <p:nvPr/>
+        </p:nvPicPr>
+        <p:blipFill>
+          <a:blip xmlns:r="http://schemas.openxmlformats.org/officeDocument/2006/relationships" xmlns:a="http://schemas.openxmlformats.org/drawingml/2006/main" r:embed="Rf1d9ffe0848c4435"/>
+          <a:stretch xmlns:a="http://schemas.openxmlformats.org/drawingml/2006/main"/>
+        </p:blipFill>
+        <p:spPr>
+          <a:xfrm xmlns:a="http://schemas.openxmlformats.org/drawingml/2006/main">
+            <a:off x="6193167" y="2133600"/>
+            <a:ext cx="5234915" cy="3990975"/>
+          </a:xfrm>
+          <a:prstGeom xmlns:a="http://schemas.openxmlformats.org/drawingml/2006/main" prst="rect">
+            <a:avLst/>
+          </a:prstGeom>
+        </p:spPr>
+      </p:pic>
+      <p:sp>
+        <p:nvSpPr>
+          <p:cNvPr id="6" name="">
             <a:extLst xmlns:a="http://schemas.openxmlformats.org/drawingml/2006/main">
               <a:ext uri="{FF2B5EF4-FFF2-40B4-BE49-F238E27FC236}">
-                <a16:creationId xmlns:a16="http://schemas.microsoft.com/office/drawing/2014/main" id="{87A455BB-D540-4CC5-ADBE-F5AAAF4C4A37}"/>
+                <a16:creationId xmlns:a16="http://schemas.microsoft.com/office/drawing/2014/main" id="{1878F9A1-3371-4B6F-99C5-A05CB8C61515}"/>
               </a:ext>
             </a:extLst>
           </p:cNvPr>
@@ -3002,8 +3012,8 @@
         </p:nvSpPr>
         <p:spPr>
           <a:xfrm xmlns:a="http://schemas.openxmlformats.org/drawingml/2006/main">
-            <a:off x="685800" y="5391150"/>
-            <a:ext cx="10572750" cy="666750"/>
+            <a:off x="685800" y="5791200"/>
+            <a:ext cx="5095875" cy="419100"/>
           </a:xfrm>
           <a:prstGeom xmlns:a="http://schemas.openxmlformats.org/drawingml/2006/main" prst="rect">
             <a:avLst/>
@@ -3020,58 +3030,35 @@
           <a:lstStyle xmlns:a="http://schemas.openxmlformats.org/drawingml/2006/main"/>
           <a:p xmlns:a="http://schemas.openxmlformats.org/drawingml/2006/main">
             <a:pPr>
-              <a:defRPr sz="1725" b="1">
-                <a:solidFill>
-                  <a:srgbClr val="F2FFCE"/>
-                </a:solidFill>
-                <a:latin typeface="Arial"/>
-                <a:ea typeface="Arial"/>
-                <a:cs typeface="Arial"/>
-              </a:defRPr>
-            </a:pPr>
-            <a:r>
-              <a:rPr sz="1725" b="1">
-                <a:solidFill>
-                  <a:srgbClr val="F2FFCE"/>
-                </a:solidFill>
-                <a:latin typeface="Arial"/>
-                <a:ea typeface="Arial"/>
-                <a:cs typeface="Arial"/>
-              </a:rPr>
-              <a:t>NO PAID BACKEND REQUIRED FOR THE JOURNAL</a:t>
-            </a:r>
-          </a:p>
-          <a:p xmlns:a="http://schemas.openxmlformats.org/drawingml/2006/main">
-            <a:pPr>
-              <a:defRPr sz="1725" b="1">
-                <a:solidFill>
-                  <a:srgbClr val="F2FFCE"/>
-                </a:solidFill>
-                <a:latin typeface="Arial"/>
-                <a:ea typeface="Arial"/>
-                <a:cs typeface="Arial"/>
-              </a:defRPr>
-            </a:pPr>
-            <a:r>
-              <a:rPr sz="1725" b="1">
-                <a:solidFill>
-                  <a:srgbClr val="F2FFCE"/>
-                </a:solidFill>
-                <a:latin typeface="Arial"/>
-                <a:ea typeface="Arial"/>
-                <a:cs typeface="Arial"/>
-              </a:rPr>
-              <a:t>Public RPC is best effort. Real-wallet validation remains pending.</a:t>
-            </a:r>
-          </a:p>
-        </p:txBody>
-      </p:sp>
-      <p:sp>
-        <p:nvSpPr>
-          <p:cNvPr id="6" name="">
+              <a:defRPr sz="1275" b="0">
+                <a:solidFill>
+                  <a:srgbClr val="FFFFFF"/>
+                </a:solidFill>
+                <a:latin typeface="Segoe UI"/>
+                <a:ea typeface="Segoe UI"/>
+                <a:cs typeface="Segoe UI"/>
+              </a:defRPr>
+            </a:pPr>
+            <a:r>
+              <a:rPr sz="1275" b="0">
+                <a:solidFill>
+                  <a:srgbClr val="FFFFFF"/>
+                </a:solidFill>
+                <a:latin typeface="Segoe UI"/>
+                <a:ea typeface="Segoe UI"/>
+                <a:cs typeface="Segoe UI"/>
+              </a:rPr>
+              <a:t>Native MWA + public RPC. Physical Seeker and live activity remain to be verified.</a:t>
+            </a:r>
+          </a:p>
+        </p:txBody>
+      </p:sp>
+      <p:sp>
+        <p:nvSpPr>
+          <p:cNvPr id="7" name="">
             <a:extLst xmlns:a="http://schemas.openxmlformats.org/drawingml/2006/main">
               <a:ext uri="{FF2B5EF4-FFF2-40B4-BE49-F238E27FC236}">
-                <a16:creationId xmlns:a16="http://schemas.microsoft.com/office/drawing/2014/main" id="{248B0679-B005-4DD4-A0EB-C9791C5300A0}"/>
+                <a16:creationId xmlns:a16="http://schemas.microsoft.com/office/drawing/2014/main" id="{F8C7AF48-A2A7-41D3-9753-A71E410E2C3C}"/>
               </a:ext>
             </a:extLst>
           </p:cNvPr>
@@ -3102,21 +3089,21 @@
             <a:pPr>
               <a:defRPr sz="1200" b="0">
                 <a:solidFill>
-                  <a:srgbClr val="F2FFCE"/>
-                </a:solidFill>
-                <a:latin typeface="Arial"/>
-                <a:ea typeface="Arial"/>
-                <a:cs typeface="Arial"/>
+                  <a:srgbClr val="D5F56B"/>
+                </a:solidFill>
+                <a:latin typeface="Segoe UI"/>
+                <a:ea typeface="Segoe UI"/>
+                <a:cs typeface="Segoe UI"/>
               </a:defRPr>
             </a:pPr>
             <a:r>
               <a:rPr sz="1200" b="0">
                 <a:solidFill>
-                  <a:srgbClr val="F2FFCE"/>
-                </a:solidFill>
-                <a:latin typeface="Arial"/>
-                <a:ea typeface="Arial"/>
-                <a:cs typeface="Arial"/>
+                  <a:srgbClr val="D5F56B"/>
+                </a:solidFill>
+                <a:latin typeface="Segoe UI"/>
+                <a:ea typeface="Segoe UI"/>
+                <a:cs typeface="Segoe UI"/>
               </a:rPr>
               <a:t>FOR THE RECORD   /   04</a:t>
             </a:r>
@@ -3126,7 +3113,7 @@
     </p:spTree>
     <p:extLst>
       <p:ext uri="{BB962C8B-B14F-4D97-AF65-F5344CB8AC3E}">
-        <p14:creationId xmlns:p14="http://schemas.microsoft.com/office/powerpoint/2010/main" val="246203569"/>
+        <p14:creationId xmlns:p14="http://schemas.microsoft.com/office/powerpoint/2010/main" val="512692457"/>
       </p:ext>
     </p:extLst>
   </p:cSld>
@@ -3139,7 +3126,7 @@
     <p:bg>
       <p:bgPr>
         <a:solidFill xmlns:a="http://schemas.openxmlformats.org/drawingml/2006/main">
-          <a:srgbClr val="FFFEFA"/>
+          <a:srgbClr val="FFFFFF"/>
         </a:solidFill>
       </p:bgPr>
     </p:bg>
@@ -3157,7 +3144,7 @@
           <p:cNvPr id="8" name="">
             <a:extLst xmlns:a="http://schemas.openxmlformats.org/drawingml/2006/main">
               <a:ext uri="{FF2B5EF4-FFF2-40B4-BE49-F238E27FC236}">
-                <a16:creationId xmlns:a16="http://schemas.microsoft.com/office/drawing/2014/main" id="{485E2995-C61C-409E-9036-CF193C212A27}"/>
+                <a16:creationId xmlns:a16="http://schemas.microsoft.com/office/drawing/2014/main" id="{7A4DDE56-6CA3-48EB-B2E2-6271CB8F06AC}"/>
               </a:ext>
             </a:extLst>
           </p:cNvPr>
@@ -3188,21 +3175,21 @@
             <a:pPr>
               <a:defRPr sz="4050" b="1">
                 <a:solidFill>
-                  <a:srgbClr val="152F2C"/>
-                </a:solidFill>
-                <a:latin typeface="Arial"/>
-                <a:ea typeface="Arial"/>
-                <a:cs typeface="Arial"/>
+                  <a:srgbClr val="191F28"/>
+                </a:solidFill>
+                <a:latin typeface="Segoe UI"/>
+                <a:ea typeface="Segoe UI"/>
+                <a:cs typeface="Segoe UI"/>
               </a:defRPr>
             </a:pPr>
             <a:r>
               <a:rPr sz="4050" b="1">
                 <a:solidFill>
-                  <a:srgbClr val="152F2C"/>
-                </a:solidFill>
-                <a:latin typeface="Arial"/>
-                <a:ea typeface="Arial"/>
-                <a:cs typeface="Arial"/>
+                  <a:srgbClr val="191F28"/>
+                </a:solidFill>
+                <a:latin typeface="Segoe UI"/>
+                <a:ea typeface="Segoe UI"/>
+                <a:cs typeface="Segoe UI"/>
               </a:rPr>
               <a:t>Clear data boundaries</a:t>
             </a:r>
@@ -3214,7 +3201,7 @@
           <p:cNvPr id="2" name="">
             <a:extLst xmlns:a="http://schemas.openxmlformats.org/drawingml/2006/main">
               <a:ext uri="{FF2B5EF4-FFF2-40B4-BE49-F238E27FC236}">
-                <a16:creationId xmlns:a16="http://schemas.microsoft.com/office/drawing/2014/main" id="{DDDCEEE2-C230-4C90-9468-809CC8AFF178}"/>
+                <a16:creationId xmlns:a16="http://schemas.microsoft.com/office/drawing/2014/main" id="{2D5A23A9-1CAE-4598-80D5-B637198EA6C3}"/>
               </a:ext>
             </a:extLst>
           </p:cNvPr>
@@ -3245,21 +3232,21 @@
             <a:pPr>
               <a:defRPr sz="2700" b="1">
                 <a:solidFill>
-                  <a:srgbClr val="096B61"/>
-                </a:solidFill>
-                <a:latin typeface="Arial"/>
-                <a:ea typeface="Arial"/>
-                <a:cs typeface="Arial"/>
+                  <a:srgbClr val="007F78"/>
+                </a:solidFill>
+                <a:latin typeface="Segoe UI"/>
+                <a:ea typeface="Segoe UI"/>
+                <a:cs typeface="Segoe UI"/>
               </a:defRPr>
             </a:pPr>
             <a:r>
               <a:rPr sz="2700" b="1">
                 <a:solidFill>
-                  <a:srgbClr val="096B61"/>
-                </a:solidFill>
-                <a:latin typeface="Arial"/>
-                <a:ea typeface="Arial"/>
-                <a:cs typeface="Arial"/>
+                  <a:srgbClr val="007F78"/>
+                </a:solidFill>
+                <a:latin typeface="Segoe UI"/>
+                <a:ea typeface="Segoe UI"/>
+                <a:cs typeface="Segoe UI"/>
               </a:rPr>
               <a:t>On the device</a:t>
             </a:r>
@@ -3271,7 +3258,7 @@
           <p:cNvPr id="3" name="">
             <a:extLst xmlns:a="http://schemas.openxmlformats.org/drawingml/2006/main">
               <a:ext uri="{FF2B5EF4-FFF2-40B4-BE49-F238E27FC236}">
-                <a16:creationId xmlns:a16="http://schemas.microsoft.com/office/drawing/2014/main" id="{3EC915A0-3715-47B7-8E15-66290C8F1703}"/>
+                <a16:creationId xmlns:a16="http://schemas.microsoft.com/office/drawing/2014/main" id="{FE306830-5AC0-402A-975F-F2EE9B7075CD}"/>
               </a:ext>
             </a:extLst>
           </p:cNvPr>
@@ -3302,21 +3289,21 @@
             <a:pPr>
               <a:defRPr sz="2250" b="0">
                 <a:solidFill>
-                  <a:srgbClr val="152F2C"/>
-                </a:solidFill>
-                <a:latin typeface="Arial"/>
-                <a:ea typeface="Arial"/>
-                <a:cs typeface="Arial"/>
+                  <a:srgbClr val="191F28"/>
+                </a:solidFill>
+                <a:latin typeface="Segoe UI"/>
+                <a:ea typeface="Segoe UI"/>
+                <a:cs typeface="Segoe UI"/>
               </a:defRPr>
             </a:pPr>
             <a:r>
               <a:rPr sz="2250" b="0">
                 <a:solidFill>
-                  <a:srgbClr val="152F2C"/>
-                </a:solidFill>
-                <a:latin typeface="Arial"/>
-                <a:ea typeface="Arial"/>
-                <a:cs typeface="Arial"/>
+                  <a:srgbClr val="191F28"/>
+                </a:solidFill>
+                <a:latin typeface="Segoe UI"/>
+                <a:ea typeface="Segoe UI"/>
+                <a:cs typeface="Segoe UI"/>
               </a:rPr>
               <a:t>SQLite keeps work records</a:t>
             </a:r>
@@ -3325,21 +3312,21 @@
             <a:pPr>
               <a:defRPr sz="2250" b="0">
                 <a:solidFill>
-                  <a:srgbClr val="152F2C"/>
-                </a:solidFill>
-                <a:latin typeface="Arial"/>
-                <a:ea typeface="Arial"/>
-                <a:cs typeface="Arial"/>
+                  <a:srgbClr val="191F28"/>
+                </a:solidFill>
+                <a:latin typeface="Segoe UI"/>
+                <a:ea typeface="Segoe UI"/>
+                <a:cs typeface="Segoe UI"/>
               </a:defRPr>
             </a:pPr>
             <a:r>
               <a:rPr sz="2250" b="0">
                 <a:solidFill>
-                  <a:srgbClr val="152F2C"/>
-                </a:solidFill>
-                <a:latin typeface="Arial"/>
-                <a:ea typeface="Arial"/>
-                <a:cs typeface="Arial"/>
+                  <a:srgbClr val="191F28"/>
+                </a:solidFill>
+                <a:latin typeface="Segoe UI"/>
+                <a:ea typeface="Segoe UI"/>
+                <a:cs typeface="Segoe UI"/>
               </a:rPr>
               <a:t>and private reflections.</a:t>
             </a:r>
@@ -3353,21 +3340,21 @@
             <a:pPr>
               <a:defRPr sz="2250" b="0">
                 <a:solidFill>
-                  <a:srgbClr val="152F2C"/>
-                </a:solidFill>
-                <a:latin typeface="Arial"/>
-                <a:ea typeface="Arial"/>
-                <a:cs typeface="Arial"/>
+                  <a:srgbClr val="191F28"/>
+                </a:solidFill>
+                <a:latin typeface="Segoe UI"/>
+                <a:ea typeface="Segoe UI"/>
+                <a:cs typeface="Segoe UI"/>
               </a:defRPr>
             </a:pPr>
             <a:r>
               <a:rPr sz="2250" b="0">
                 <a:solidFill>
-                  <a:srgbClr val="152F2C"/>
-                </a:solidFill>
-                <a:latin typeface="Arial"/>
-                <a:ea typeface="Arial"/>
-                <a:cs typeface="Arial"/>
+                  <a:srgbClr val="191F28"/>
+                </a:solidFill>
+                <a:latin typeface="Segoe UI"/>
+                <a:ea typeface="Segoe UI"/>
+                <a:cs typeface="Segoe UI"/>
               </a:rPr>
               <a:t>JSON export gives users</a:t>
             </a:r>
@@ -3376,21 +3363,21 @@
             <a:pPr>
               <a:defRPr sz="2250" b="0">
                 <a:solidFill>
-                  <a:srgbClr val="152F2C"/>
-                </a:solidFill>
-                <a:latin typeface="Arial"/>
-                <a:ea typeface="Arial"/>
-                <a:cs typeface="Arial"/>
+                  <a:srgbClr val="191F28"/>
+                </a:solidFill>
+                <a:latin typeface="Segoe UI"/>
+                <a:ea typeface="Segoe UI"/>
+                <a:cs typeface="Segoe UI"/>
               </a:defRPr>
             </a:pPr>
             <a:r>
               <a:rPr sz="2250" b="0">
                 <a:solidFill>
-                  <a:srgbClr val="152F2C"/>
-                </a:solidFill>
-                <a:latin typeface="Arial"/>
-                <a:ea typeface="Arial"/>
-                <a:cs typeface="Arial"/>
+                  <a:srgbClr val="191F28"/>
+                </a:solidFill>
+                <a:latin typeface="Segoe UI"/>
+                <a:ea typeface="Segoe UI"/>
+                <a:cs typeface="Segoe UI"/>
               </a:rPr>
               <a:t>a portable copy.</a:t>
             </a:r>
@@ -3402,7 +3389,7 @@
           <p:cNvPr id="4" name="">
             <a:extLst xmlns:a="http://schemas.openxmlformats.org/drawingml/2006/main">
               <a:ext uri="{FF2B5EF4-FFF2-40B4-BE49-F238E27FC236}">
-                <a16:creationId xmlns:a16="http://schemas.microsoft.com/office/drawing/2014/main" id="{3768EF5A-0FAF-4F63-897F-E9AFDB18EFC3}"/>
+                <a16:creationId xmlns:a16="http://schemas.microsoft.com/office/drawing/2014/main" id="{6C485978-CBC2-454A-8728-F80B0398354A}"/>
               </a:ext>
             </a:extLst>
           </p:cNvPr>
@@ -3433,21 +3420,21 @@
             <a:pPr>
               <a:defRPr sz="2700" b="1">
                 <a:solidFill>
-                  <a:srgbClr val="096B61"/>
-                </a:solidFill>
-                <a:latin typeface="Arial"/>
-                <a:ea typeface="Arial"/>
-                <a:cs typeface="Arial"/>
+                  <a:srgbClr val="007F78"/>
+                </a:solidFill>
+                <a:latin typeface="Segoe UI"/>
+                <a:ea typeface="Segoe UI"/>
+                <a:cs typeface="Segoe UI"/>
               </a:defRPr>
             </a:pPr>
             <a:r>
               <a:rPr sz="2700" b="1">
                 <a:solidFill>
-                  <a:srgbClr val="096B61"/>
-                </a:solidFill>
-                <a:latin typeface="Arial"/>
-                <a:ea typeface="Arial"/>
-                <a:cs typeface="Arial"/>
+                  <a:srgbClr val="007F78"/>
+                </a:solidFill>
+                <a:latin typeface="Segoe UI"/>
+                <a:ea typeface="Segoe UI"/>
+                <a:cs typeface="Segoe UI"/>
               </a:rPr>
               <a:t>Direct wallet reads</a:t>
             </a:r>
@@ -3459,7 +3446,7 @@
           <p:cNvPr id="5" name="">
             <a:extLst xmlns:a="http://schemas.openxmlformats.org/drawingml/2006/main">
               <a:ext uri="{FF2B5EF4-FFF2-40B4-BE49-F238E27FC236}">
-                <a16:creationId xmlns:a16="http://schemas.microsoft.com/office/drawing/2014/main" id="{3D44444F-7F3B-45ED-B7C7-BF6D698247F6}"/>
+                <a16:creationId xmlns:a16="http://schemas.microsoft.com/office/drawing/2014/main" id="{C3D2C96C-B8FB-4CCA-82CE-013EF02F6BD9}"/>
               </a:ext>
             </a:extLst>
           </p:cNvPr>
@@ -3490,21 +3477,21 @@
             <a:pPr>
               <a:defRPr sz="2250" b="0">
                 <a:solidFill>
-                  <a:srgbClr val="152F2C"/>
-                </a:solidFill>
-                <a:latin typeface="Arial"/>
-                <a:ea typeface="Arial"/>
-                <a:cs typeface="Arial"/>
+                  <a:srgbClr val="191F28"/>
+                </a:solidFill>
+                <a:latin typeface="Segoe UI"/>
+                <a:ea typeface="Segoe UI"/>
+                <a:cs typeface="Segoe UI"/>
               </a:defRPr>
             </a:pPr>
             <a:r>
               <a:rPr sz="2250" b="0">
                 <a:solidFill>
-                  <a:srgbClr val="152F2C"/>
-                </a:solidFill>
-                <a:latin typeface="Arial"/>
-                <a:ea typeface="Arial"/>
-                <a:cs typeface="Arial"/>
+                  <a:srgbClr val="191F28"/>
+                </a:solidFill>
+                <a:latin typeface="Segoe UI"/>
+                <a:ea typeface="Segoe UI"/>
+                <a:cs typeface="Segoe UI"/>
               </a:rPr>
               <a:t>MWA supplies the selected</a:t>
             </a:r>
@@ -3513,21 +3500,21 @@
             <a:pPr>
               <a:defRPr sz="2250" b="0">
                 <a:solidFill>
-                  <a:srgbClr val="152F2C"/>
-                </a:solidFill>
-                <a:latin typeface="Arial"/>
-                <a:ea typeface="Arial"/>
-                <a:cs typeface="Arial"/>
+                  <a:srgbClr val="191F28"/>
+                </a:solidFill>
+                <a:latin typeface="Segoe UI"/>
+                <a:ea typeface="Segoe UI"/>
+                <a:cs typeface="Segoe UI"/>
               </a:defRPr>
             </a:pPr>
             <a:r>
               <a:rPr sz="2250" b="0">
                 <a:solidFill>
-                  <a:srgbClr val="152F2C"/>
-                </a:solidFill>
-                <a:latin typeface="Arial"/>
-                <a:ea typeface="Arial"/>
-                <a:cs typeface="Arial"/>
+                  <a:srgbClr val="191F28"/>
+                </a:solidFill>
+                <a:latin typeface="Segoe UI"/>
+                <a:ea typeface="Segoe UI"/>
+                <a:cs typeface="Segoe UI"/>
               </a:rPr>
               <a:t>public wallet account.</a:t>
             </a:r>
@@ -3541,21 +3528,21 @@
             <a:pPr>
               <a:defRPr sz="2250" b="0">
                 <a:solidFill>
-                  <a:srgbClr val="152F2C"/>
-                </a:solidFill>
-                <a:latin typeface="Arial"/>
-                <a:ea typeface="Arial"/>
-                <a:cs typeface="Arial"/>
+                  <a:srgbClr val="191F28"/>
+                </a:solidFill>
+                <a:latin typeface="Segoe UI"/>
+                <a:ea typeface="Segoe UI"/>
+                <a:cs typeface="Segoe UI"/>
               </a:defRPr>
             </a:pPr>
             <a:r>
               <a:rPr sz="2250" b="0">
                 <a:solidFill>
-                  <a:srgbClr val="152F2C"/>
-                </a:solidFill>
-                <a:latin typeface="Arial"/>
-                <a:ea typeface="Arial"/>
-                <a:cs typeface="Arial"/>
+                  <a:srgbClr val="191F28"/>
+                </a:solidFill>
+                <a:latin typeface="Segoe UI"/>
+                <a:ea typeface="Segoe UI"/>
+                <a:cs typeface="Segoe UI"/>
               </a:rPr>
               <a:t>Public RPC supplies</a:t>
             </a:r>
@@ -3564,21 +3551,21 @@
             <a:pPr>
               <a:defRPr sz="2250" b="0">
                 <a:solidFill>
-                  <a:srgbClr val="152F2C"/>
-                </a:solidFill>
-                <a:latin typeface="Arial"/>
-                <a:ea typeface="Arial"/>
-                <a:cs typeface="Arial"/>
+                  <a:srgbClr val="191F28"/>
+                </a:solidFill>
+                <a:latin typeface="Segoe UI"/>
+                <a:ea typeface="Segoe UI"/>
+                <a:cs typeface="Segoe UI"/>
               </a:defRPr>
             </a:pPr>
             <a:r>
               <a:rPr sz="2250" b="0">
                 <a:solidFill>
-                  <a:srgbClr val="152F2C"/>
-                </a:solidFill>
-                <a:latin typeface="Arial"/>
-                <a:ea typeface="Arial"/>
-                <a:cs typeface="Arial"/>
+                  <a:srgbClr val="191F28"/>
+                </a:solidFill>
+                <a:latin typeface="Segoe UI"/>
+                <a:ea typeface="Segoe UI"/>
+                <a:cs typeface="Segoe UI"/>
               </a:rPr>
               <a:t>finalized activity.</a:t>
             </a:r>
@@ -3590,7 +3577,7 @@
           <p:cNvPr id="6" name="">
             <a:extLst xmlns:a="http://schemas.openxmlformats.org/drawingml/2006/main">
               <a:ext uri="{FF2B5EF4-FFF2-40B4-BE49-F238E27FC236}">
-                <a16:creationId xmlns:a16="http://schemas.microsoft.com/office/drawing/2014/main" id="{9D571D78-5C9B-4617-B14A-A09783AFE60C}"/>
+                <a16:creationId xmlns:a16="http://schemas.microsoft.com/office/drawing/2014/main" id="{D25723E7-40C2-4800-A3F4-3051BCB4E21A}"/>
               </a:ext>
             </a:extLst>
           </p:cNvPr>
@@ -3621,21 +3608,21 @@
             <a:pPr>
               <a:defRPr sz="1650" b="0">
                 <a:solidFill>
-                  <a:srgbClr val="526762"/>
-                </a:solidFill>
-                <a:latin typeface="Arial"/>
-                <a:ea typeface="Arial"/>
-                <a:cs typeface="Arial"/>
+                  <a:srgbClr val="667085"/>
+                </a:solidFill>
+                <a:latin typeface="Segoe UI"/>
+                <a:ea typeface="Segoe UI"/>
+                <a:cs typeface="Segoe UI"/>
               </a:defRPr>
             </a:pPr>
             <a:r>
               <a:rPr sz="1650" b="0">
                 <a:solidFill>
-                  <a:srgbClr val="526762"/>
-                </a:solidFill>
-                <a:latin typeface="Arial"/>
-                <a:ea typeface="Arial"/>
-                <a:cs typeface="Arial"/>
+                  <a:srgbClr val="667085"/>
+                </a:solidFill>
+                <a:latin typeface="Segoe UI"/>
+                <a:ea typeface="Segoe UI"/>
+                <a:cs typeface="Segoe UI"/>
               </a:rPr>
               <a:t>No paid server is required for the journal. Optional shared rooms and purchases remain separate.</a:t>
             </a:r>
@@ -3647,7 +3634,7 @@
           <p:cNvPr id="7" name="">
             <a:extLst xmlns:a="http://schemas.openxmlformats.org/drawingml/2006/main">
               <a:ext uri="{FF2B5EF4-FFF2-40B4-BE49-F238E27FC236}">
-                <a16:creationId xmlns:a16="http://schemas.microsoft.com/office/drawing/2014/main" id="{9FE624F8-27CF-4058-98B3-00AFAB710A8A}"/>
+                <a16:creationId xmlns:a16="http://schemas.microsoft.com/office/drawing/2014/main" id="{F0B1D377-5E01-4C6E-B5DB-ED9E25F50DB5}"/>
               </a:ext>
             </a:extLst>
           </p:cNvPr>
@@ -3678,21 +3665,21 @@
             <a:pPr>
               <a:defRPr sz="1200" b="0">
                 <a:solidFill>
-                  <a:srgbClr val="526762"/>
-                </a:solidFill>
-                <a:latin typeface="Arial"/>
-                <a:ea typeface="Arial"/>
-                <a:cs typeface="Arial"/>
+                  <a:srgbClr val="667085"/>
+                </a:solidFill>
+                <a:latin typeface="Segoe UI"/>
+                <a:ea typeface="Segoe UI"/>
+                <a:cs typeface="Segoe UI"/>
               </a:defRPr>
             </a:pPr>
             <a:r>
               <a:rPr sz="1200" b="0">
                 <a:solidFill>
-                  <a:srgbClr val="526762"/>
-                </a:solidFill>
-                <a:latin typeface="Arial"/>
-                <a:ea typeface="Arial"/>
-                <a:cs typeface="Arial"/>
+                  <a:srgbClr val="667085"/>
+                </a:solidFill>
+                <a:latin typeface="Segoe UI"/>
+                <a:ea typeface="Segoe UI"/>
+                <a:cs typeface="Segoe UI"/>
               </a:rPr>
               <a:t>FOR THE RECORD   /   05</a:t>
             </a:r>
@@ -3702,7 +3689,7 @@
     </p:spTree>
     <p:extLst>
       <p:ext uri="{BB962C8B-B14F-4D97-AF65-F5344CB8AC3E}">
-        <p14:creationId xmlns:p14="http://schemas.microsoft.com/office/powerpoint/2010/main" val="1246546623"/>
+        <p14:creationId xmlns:p14="http://schemas.microsoft.com/office/powerpoint/2010/main" val="2040531904"/>
       </p:ext>
     </p:extLst>
   </p:cSld>
@@ -3715,7 +3702,7 @@
     <p:bg>
       <p:bgPr>
         <a:solidFill xmlns:a="http://schemas.openxmlformats.org/drawingml/2006/main">
-          <a:srgbClr val="F0F5F1"/>
+          <a:srgbClr val="F4F5F7"/>
         </a:solidFill>
       </p:bgPr>
     </p:bg>
@@ -3733,7 +3720,7 @@
           <p:cNvPr id="7" name="">
             <a:extLst xmlns:a="http://schemas.openxmlformats.org/drawingml/2006/main">
               <a:ext uri="{FF2B5EF4-FFF2-40B4-BE49-F238E27FC236}">
-                <a16:creationId xmlns:a16="http://schemas.microsoft.com/office/drawing/2014/main" id="{0FB1E8ED-3E76-4B28-BA50-6E55C0176557}"/>
+                <a16:creationId xmlns:a16="http://schemas.microsoft.com/office/drawing/2014/main" id="{4B02B898-7974-4F5D-86F3-5116A96F14DD}"/>
               </a:ext>
             </a:extLst>
           </p:cNvPr>
@@ -3764,21 +3751,21 @@
             <a:pPr>
               <a:defRPr sz="3975" b="1">
                 <a:solidFill>
-                  <a:srgbClr val="152F2C"/>
-                </a:solidFill>
-                <a:latin typeface="Arial"/>
-                <a:ea typeface="Arial"/>
-                <a:cs typeface="Arial"/>
+                  <a:srgbClr val="191F28"/>
+                </a:solidFill>
+                <a:latin typeface="Segoe UI"/>
+                <a:ea typeface="Segoe UI"/>
+                <a:cs typeface="Segoe UI"/>
               </a:defRPr>
             </a:pPr>
             <a:r>
               <a:rPr sz="3975" b="1">
                 <a:solidFill>
-                  <a:srgbClr val="152F2C"/>
-                </a:solidFill>
-                <a:latin typeface="Arial"/>
-                <a:ea typeface="Arial"/>
-                <a:cs typeface="Arial"/>
+                  <a:srgbClr val="191F28"/>
+                </a:solidFill>
+                <a:latin typeface="Segoe UI"/>
+                <a:ea typeface="Segoe UI"/>
+                <a:cs typeface="Segoe UI"/>
               </a:rPr>
               <a:t>An approachable</a:t>
             </a:r>
@@ -3787,21 +3774,21 @@
             <a:pPr>
               <a:defRPr sz="3975" b="1">
                 <a:solidFill>
-                  <a:srgbClr val="152F2C"/>
-                </a:solidFill>
-                <a:latin typeface="Arial"/>
-                <a:ea typeface="Arial"/>
-                <a:cs typeface="Arial"/>
+                  <a:srgbClr val="191F28"/>
+                </a:solidFill>
+                <a:latin typeface="Segoe UI"/>
+                <a:ea typeface="Segoe UI"/>
+                <a:cs typeface="Segoe UI"/>
               </a:defRPr>
             </a:pPr>
             <a:r>
               <a:rPr sz="3975" b="1">
                 <a:solidFill>
-                  <a:srgbClr val="152F2C"/>
-                </a:solidFill>
-                <a:latin typeface="Arial"/>
-                <a:ea typeface="Arial"/>
-                <a:cs typeface="Arial"/>
+                  <a:srgbClr val="191F28"/>
+                </a:solidFill>
+                <a:latin typeface="Segoe UI"/>
+                <a:ea typeface="Segoe UI"/>
+                <a:cs typeface="Segoe UI"/>
               </a:rPr>
               <a:t>phone experience</a:t>
             </a:r>
@@ -3813,7 +3800,7 @@
           <p:cNvPr id="2" name="">
             <a:extLst xmlns:a="http://schemas.openxmlformats.org/drawingml/2006/main">
               <a:ext uri="{FF2B5EF4-FFF2-40B4-BE49-F238E27FC236}">
-                <a16:creationId xmlns:a16="http://schemas.microsoft.com/office/drawing/2014/main" id="{2FAA8EF1-AD7F-47FA-BB50-B4EA8E566E12}"/>
+                <a16:creationId xmlns:a16="http://schemas.microsoft.com/office/drawing/2014/main" id="{42587C2A-BBD2-4D72-8BF6-A076B96AD785}"/>
               </a:ext>
             </a:extLst>
           </p:cNvPr>
@@ -3844,21 +3831,21 @@
             <a:pPr>
               <a:defRPr sz="2175" b="0">
                 <a:solidFill>
-                  <a:srgbClr val="152F2C"/>
-                </a:solidFill>
-                <a:latin typeface="Arial"/>
-                <a:ea typeface="Arial"/>
-                <a:cs typeface="Arial"/>
+                  <a:srgbClr val="191F28"/>
+                </a:solidFill>
+                <a:latin typeface="Segoe UI"/>
+                <a:ea typeface="Segoe UI"/>
+                <a:cs typeface="Segoe UI"/>
               </a:defRPr>
             </a:pPr>
             <a:r>
               <a:rPr sz="2175" b="0">
                 <a:solidFill>
-                  <a:srgbClr val="152F2C"/>
-                </a:solidFill>
-                <a:latin typeface="Arial"/>
-                <a:ea typeface="Arial"/>
-                <a:cs typeface="Arial"/>
+                  <a:srgbClr val="191F28"/>
+                </a:solidFill>
+                <a:latin typeface="Segoe UI"/>
+                <a:ea typeface="Segoe UI"/>
+                <a:cs typeface="Segoe UI"/>
               </a:rPr>
               <a:t>English by default. Eight language choices.</a:t>
             </a:r>
@@ -3867,21 +3854,21 @@
             <a:pPr>
               <a:defRPr sz="2175" b="0">
                 <a:solidFill>
-                  <a:srgbClr val="152F2C"/>
-                </a:solidFill>
-                <a:latin typeface="Arial"/>
-                <a:ea typeface="Arial"/>
-                <a:cs typeface="Arial"/>
+                  <a:srgbClr val="191F28"/>
+                </a:solidFill>
+                <a:latin typeface="Segoe UI"/>
+                <a:ea typeface="Segoe UI"/>
+                <a:cs typeface="Segoe UI"/>
               </a:defRPr>
             </a:pPr>
             <a:r>
               <a:rPr sz="2175" b="0">
                 <a:solidFill>
-                  <a:srgbClr val="152F2C"/>
-                </a:solidFill>
-                <a:latin typeface="Arial"/>
-                <a:ea typeface="Arial"/>
-                <a:cs typeface="Arial"/>
+                  <a:srgbClr val="191F28"/>
+                </a:solidFill>
+                <a:latin typeface="Segoe UI"/>
+                <a:ea typeface="Segoe UI"/>
+                <a:cs typeface="Segoe UI"/>
               </a:rPr>
               <a:t>Your own writing keeps its language.</a:t>
             </a:r>
@@ -3893,7 +3880,7 @@
           <p:cNvPr id="3" name="">
             <a:extLst xmlns:a="http://schemas.openxmlformats.org/drawingml/2006/main">
               <a:ext uri="{FF2B5EF4-FFF2-40B4-BE49-F238E27FC236}">
-                <a16:creationId xmlns:a16="http://schemas.microsoft.com/office/drawing/2014/main" id="{A85F59E7-84B4-4548-A49B-F42EF92B32A2}"/>
+                <a16:creationId xmlns:a16="http://schemas.microsoft.com/office/drawing/2014/main" id="{5A2B9BB1-54A4-4ADB-81B4-511B240AC262}"/>
               </a:ext>
             </a:extLst>
           </p:cNvPr>
@@ -3924,21 +3911,21 @@
             <a:pPr>
               <a:defRPr sz="2100" b="0">
                 <a:solidFill>
-                  <a:srgbClr val="152F2C"/>
-                </a:solidFill>
-                <a:latin typeface="Arial"/>
-                <a:ea typeface="Arial"/>
-                <a:cs typeface="Arial"/>
+                  <a:srgbClr val="191F28"/>
+                </a:solidFill>
+                <a:latin typeface="Segoe UI"/>
+                <a:ea typeface="Segoe UI"/>
+                <a:cs typeface="Segoe UI"/>
               </a:defRPr>
             </a:pPr>
             <a:r>
               <a:rPr sz="2100" b="0">
                 <a:solidFill>
-                  <a:srgbClr val="152F2C"/>
-                </a:solidFill>
-                <a:latin typeface="Arial"/>
-                <a:ea typeface="Arial"/>
-                <a:cs typeface="Arial"/>
+                  <a:srgbClr val="191F28"/>
+                </a:solidFill>
+                <a:latin typeface="Segoe UI"/>
+                <a:ea typeface="Segoe UI"/>
+                <a:cs typeface="Segoe UI"/>
               </a:rPr>
               <a:t>Optional motion, haptics and reminders.</a:t>
             </a:r>
@@ -3947,21 +3934,21 @@
             <a:pPr>
               <a:defRPr sz="2100" b="0">
                 <a:solidFill>
-                  <a:srgbClr val="152F2C"/>
-                </a:solidFill>
-                <a:latin typeface="Arial"/>
-                <a:ea typeface="Arial"/>
-                <a:cs typeface="Arial"/>
+                  <a:srgbClr val="191F28"/>
+                </a:solidFill>
+                <a:latin typeface="Segoe UI"/>
+                <a:ea typeface="Segoe UI"/>
+                <a:cs typeface="Segoe UI"/>
               </a:defRPr>
             </a:pPr>
             <a:r>
               <a:rPr sz="2100" b="0">
                 <a:solidFill>
-                  <a:srgbClr val="152F2C"/>
-                </a:solidFill>
-                <a:latin typeface="Arial"/>
-                <a:ea typeface="Arial"/>
-                <a:cs typeface="Arial"/>
+                  <a:srgbClr val="191F28"/>
+                </a:solidFill>
+                <a:latin typeface="Segoe UI"/>
+                <a:ea typeface="Segoe UI"/>
+                <a:cs typeface="Segoe UI"/>
               </a:rPr>
               <a:t>Clear save and recovery states.</a:t>
             </a:r>
@@ -3970,21 +3957,21 @@
             <a:pPr>
               <a:defRPr sz="2100" b="0">
                 <a:solidFill>
-                  <a:srgbClr val="152F2C"/>
-                </a:solidFill>
-                <a:latin typeface="Arial"/>
-                <a:ea typeface="Arial"/>
-                <a:cs typeface="Arial"/>
+                  <a:srgbClr val="191F28"/>
+                </a:solidFill>
+                <a:latin typeface="Segoe UI"/>
+                <a:ea typeface="Segoe UI"/>
+                <a:cs typeface="Segoe UI"/>
               </a:defRPr>
             </a:pPr>
             <a:r>
               <a:rPr sz="2100" b="0">
                 <a:solidFill>
-                  <a:srgbClr val="152F2C"/>
-                </a:solidFill>
-                <a:latin typeface="Arial"/>
-                <a:ea typeface="Arial"/>
-                <a:cs typeface="Arial"/>
+                  <a:srgbClr val="191F28"/>
+                </a:solidFill>
+                <a:latin typeface="Segoe UI"/>
+                <a:ea typeface="Segoe UI"/>
+                <a:cs typeface="Segoe UI"/>
               </a:rPr>
               <a:t>Local usefulness without a network.</a:t>
             </a:r>
@@ -4000,7 +3987,7 @@
           <p:nvPr/>
         </p:nvPicPr>
         <p:blipFill>
-          <a:blip xmlns:r="http://schemas.openxmlformats.org/officeDocument/2006/relationships" xmlns:a="http://schemas.openxmlformats.org/drawingml/2006/main" r:embed="R3f2f455f4427432b"/>
+          <a:blip xmlns:r="http://schemas.openxmlformats.org/officeDocument/2006/relationships" xmlns:a="http://schemas.openxmlformats.org/drawingml/2006/main" r:embed="Rf0251c0c1cc641f7"/>
           <a:stretch xmlns:a="http://schemas.openxmlformats.org/drawingml/2006/main"/>
         </p:blipFill>
         <p:spPr>
@@ -4018,7 +4005,7 @@
           <p:cNvPr id="5" name="">
             <a:extLst xmlns:a="http://schemas.openxmlformats.org/drawingml/2006/main">
               <a:ext uri="{FF2B5EF4-FFF2-40B4-BE49-F238E27FC236}">
-                <a16:creationId xmlns:a16="http://schemas.microsoft.com/office/drawing/2014/main" id="{BAD3E106-F2A9-4EB6-9036-FAE1BC2A92F7}"/>
+                <a16:creationId xmlns:a16="http://schemas.microsoft.com/office/drawing/2014/main" id="{A0E89F76-820B-4B80-B973-0367F561EBA9}"/>
               </a:ext>
             </a:extLst>
           </p:cNvPr>
@@ -4049,21 +4036,21 @@
             <a:pPr>
               <a:defRPr sz="1875" b="1">
                 <a:solidFill>
-                  <a:srgbClr val="096B61"/>
-                </a:solidFill>
-                <a:latin typeface="Arial"/>
-                <a:ea typeface="Arial"/>
-                <a:cs typeface="Arial"/>
+                  <a:srgbClr val="007F78"/>
+                </a:solidFill>
+                <a:latin typeface="Segoe UI"/>
+                <a:ea typeface="Segoe UI"/>
+                <a:cs typeface="Segoe UI"/>
               </a:defRPr>
             </a:pPr>
             <a:r>
               <a:rPr sz="1875" b="1">
                 <a:solidFill>
-                  <a:srgbClr val="096B61"/>
-                </a:solidFill>
-                <a:latin typeface="Arial"/>
-                <a:ea typeface="Arial"/>
-                <a:cs typeface="Arial"/>
+                  <a:srgbClr val="007F78"/>
+                </a:solidFill>
+                <a:latin typeface="Segoe UI"/>
+                <a:ea typeface="Segoe UI"/>
+                <a:cs typeface="Segoe UI"/>
               </a:rPr>
               <a:t>EN  KO  JA  ZH  HI  ES  PT  FR</a:t>
             </a:r>
@@ -4075,7 +4062,7 @@
           <p:cNvPr id="6" name="">
             <a:extLst xmlns:a="http://schemas.openxmlformats.org/drawingml/2006/main">
               <a:ext uri="{FF2B5EF4-FFF2-40B4-BE49-F238E27FC236}">
-                <a16:creationId xmlns:a16="http://schemas.microsoft.com/office/drawing/2014/main" id="{A46C7732-1FD3-4889-B0BE-D5306D8DD422}"/>
+                <a16:creationId xmlns:a16="http://schemas.microsoft.com/office/drawing/2014/main" id="{33EE80DA-88AD-4AC0-A3FF-059F1FB36460}"/>
               </a:ext>
             </a:extLst>
           </p:cNvPr>
@@ -4106,21 +4093,21 @@
             <a:pPr>
               <a:defRPr sz="1200" b="0">
                 <a:solidFill>
-                  <a:srgbClr val="526762"/>
-                </a:solidFill>
-                <a:latin typeface="Arial"/>
-                <a:ea typeface="Arial"/>
-                <a:cs typeface="Arial"/>
+                  <a:srgbClr val="667085"/>
+                </a:solidFill>
+                <a:latin typeface="Segoe UI"/>
+                <a:ea typeface="Segoe UI"/>
+                <a:cs typeface="Segoe UI"/>
               </a:defRPr>
             </a:pPr>
             <a:r>
               <a:rPr sz="1200" b="0">
                 <a:solidFill>
-                  <a:srgbClr val="526762"/>
-                </a:solidFill>
-                <a:latin typeface="Arial"/>
-                <a:ea typeface="Arial"/>
-                <a:cs typeface="Arial"/>
+                  <a:srgbClr val="667085"/>
+                </a:solidFill>
+                <a:latin typeface="Segoe UI"/>
+                <a:ea typeface="Segoe UI"/>
+                <a:cs typeface="Segoe UI"/>
               </a:rPr>
               <a:t>FOR THE RECORD   /   06</a:t>
             </a:r>
@@ -4130,7 +4117,7 @@
     </p:spTree>
     <p:extLst>
       <p:ext uri="{BB962C8B-B14F-4D97-AF65-F5344CB8AC3E}">
-        <p14:creationId xmlns:p14="http://schemas.microsoft.com/office/powerpoint/2010/main" val="168040093"/>
+        <p14:creationId xmlns:p14="http://schemas.microsoft.com/office/powerpoint/2010/main" val="1722821122"/>
       </p:ext>
     </p:extLst>
   </p:cSld>
@@ -4143,7 +4130,7 @@
     <p:bg>
       <p:bgPr>
         <a:solidFill xmlns:a="http://schemas.openxmlformats.org/drawingml/2006/main">
-          <a:srgbClr val="FFFEFA"/>
+          <a:srgbClr val="FFFFFF"/>
         </a:solidFill>
       </p:bgPr>
     </p:bg>
@@ -4161,7 +4148,7 @@
           <p:cNvPr id="8" name="">
             <a:extLst xmlns:a="http://schemas.openxmlformats.org/drawingml/2006/main">
               <a:ext uri="{FF2B5EF4-FFF2-40B4-BE49-F238E27FC236}">
-                <a16:creationId xmlns:a16="http://schemas.microsoft.com/office/drawing/2014/main" id="{7FAF999E-3EA3-45AB-99F5-AA439DB1E03C}"/>
+                <a16:creationId xmlns:a16="http://schemas.microsoft.com/office/drawing/2014/main" id="{A7E9D035-FCCD-457F-AE2C-1C5FB477151F}"/>
               </a:ext>
             </a:extLst>
           </p:cNvPr>
@@ -4192,21 +4179,21 @@
             <a:pPr>
               <a:defRPr sz="4050" b="1">
                 <a:solidFill>
-                  <a:srgbClr val="152F2C"/>
-                </a:solidFill>
-                <a:latin typeface="Arial"/>
-                <a:ea typeface="Arial"/>
-                <a:cs typeface="Arial"/>
+                  <a:srgbClr val="191F28"/>
+                </a:solidFill>
+                <a:latin typeface="Segoe UI"/>
+                <a:ea typeface="Segoe UI"/>
+                <a:cs typeface="Segoe UI"/>
               </a:defRPr>
             </a:pPr>
             <a:r>
               <a:rPr sz="4050" b="1">
                 <a:solidFill>
-                  <a:srgbClr val="152F2C"/>
-                </a:solidFill>
-                <a:latin typeface="Arial"/>
-                <a:ea typeface="Arial"/>
-                <a:cs typeface="Arial"/>
+                  <a:srgbClr val="191F28"/>
+                </a:solidFill>
+                <a:latin typeface="Segoe UI"/>
+                <a:ea typeface="Segoe UI"/>
+                <a:cs typeface="Segoe UI"/>
               </a:rPr>
               <a:t>Delivery status</a:t>
             </a:r>
@@ -4218,7 +4205,7 @@
           <p:cNvPr id="2" name="">
             <a:extLst xmlns:a="http://schemas.openxmlformats.org/drawingml/2006/main">
               <a:ext uri="{FF2B5EF4-FFF2-40B4-BE49-F238E27FC236}">
-                <a16:creationId xmlns:a16="http://schemas.microsoft.com/office/drawing/2014/main" id="{86AE297C-A844-45EC-AFB3-71F61EE16E95}"/>
+                <a16:creationId xmlns:a16="http://schemas.microsoft.com/office/drawing/2014/main" id="{25C92CBF-0C71-47BC-8B56-39BD3B384913}"/>
               </a:ext>
             </a:extLst>
           </p:cNvPr>
@@ -4249,21 +4236,21 @@
             <a:pPr>
               <a:defRPr sz="2700" b="1">
                 <a:solidFill>
-                  <a:srgbClr val="096B61"/>
-                </a:solidFill>
-                <a:latin typeface="Arial"/>
-                <a:ea typeface="Arial"/>
-                <a:cs typeface="Arial"/>
+                  <a:srgbClr val="007F78"/>
+                </a:solidFill>
+                <a:latin typeface="Segoe UI"/>
+                <a:ea typeface="Segoe UI"/>
+                <a:cs typeface="Segoe UI"/>
               </a:defRPr>
             </a:pPr>
             <a:r>
               <a:rPr sz="2700" b="1">
                 <a:solidFill>
-                  <a:srgbClr val="096B61"/>
-                </a:solidFill>
-                <a:latin typeface="Arial"/>
-                <a:ea typeface="Arial"/>
-                <a:cs typeface="Arial"/>
+                  <a:srgbClr val="007F78"/>
+                </a:solidFill>
+                <a:latin typeface="Segoe UI"/>
+                <a:ea typeface="Segoe UI"/>
+                <a:cs typeface="Segoe UI"/>
               </a:rPr>
               <a:t>Implemented</a:t>
             </a:r>
@@ -4275,7 +4262,7 @@
           <p:cNvPr id="3" name="">
             <a:extLst xmlns:a="http://schemas.openxmlformats.org/drawingml/2006/main">
               <a:ext uri="{FF2B5EF4-FFF2-40B4-BE49-F238E27FC236}">
-                <a16:creationId xmlns:a16="http://schemas.microsoft.com/office/drawing/2014/main" id="{FDC61460-BD95-4401-95BA-43D2CA66984D}"/>
+                <a16:creationId xmlns:a16="http://schemas.microsoft.com/office/drawing/2014/main" id="{E2A1D9E0-D7E0-4648-B03B-E348FFBBE032}"/>
               </a:ext>
             </a:extLst>
           </p:cNvPr>
@@ -4306,21 +4293,21 @@
             <a:pPr>
               <a:defRPr sz="2250" b="0">
                 <a:solidFill>
-                  <a:srgbClr val="152F2C"/>
-                </a:solidFill>
-                <a:latin typeface="Arial"/>
-                <a:ea typeface="Arial"/>
-                <a:cs typeface="Arial"/>
+                  <a:srgbClr val="191F28"/>
+                </a:solidFill>
+                <a:latin typeface="Segoe UI"/>
+                <a:ea typeface="Segoe UI"/>
+                <a:cs typeface="Segoe UI"/>
               </a:defRPr>
             </a:pPr>
             <a:r>
               <a:rPr sz="2250" b="0">
                 <a:solidFill>
-                  <a:srgbClr val="152F2C"/>
-                </a:solidFill>
-                <a:latin typeface="Arial"/>
-                <a:ea typeface="Arial"/>
-                <a:cs typeface="Arial"/>
+                  <a:srgbClr val="191F28"/>
+                </a:solidFill>
+                <a:latin typeface="Segoe UI"/>
+                <a:ea typeface="Segoe UI"/>
+                <a:cs typeface="Segoe UI"/>
               </a:rPr>
               <a:t>Offline work journal</a:t>
             </a:r>
@@ -4329,21 +4316,21 @@
             <a:pPr>
               <a:defRPr sz="2250" b="0">
                 <a:solidFill>
-                  <a:srgbClr val="152F2C"/>
-                </a:solidFill>
-                <a:latin typeface="Arial"/>
-                <a:ea typeface="Arial"/>
-                <a:cs typeface="Arial"/>
+                  <a:srgbClr val="191F28"/>
+                </a:solidFill>
+                <a:latin typeface="Segoe UI"/>
+                <a:ea typeface="Segoe UI"/>
+                <a:cs typeface="Segoe UI"/>
               </a:defRPr>
             </a:pPr>
             <a:r>
               <a:rPr sz="2250" b="0">
                 <a:solidFill>
-                  <a:srgbClr val="152F2C"/>
-                </a:solidFill>
-                <a:latin typeface="Arial"/>
-                <a:ea typeface="Arial"/>
-                <a:cs typeface="Arial"/>
+                  <a:srgbClr val="191F28"/>
+                </a:solidFill>
+                <a:latin typeface="Segoe UI"/>
+                <a:ea typeface="Segoe UI"/>
+                <a:cs typeface="Segoe UI"/>
               </a:rPr>
               <a:t>Private reflection storage</a:t>
             </a:r>
@@ -4352,21 +4339,21 @@
             <a:pPr>
               <a:defRPr sz="2250" b="0">
                 <a:solidFill>
-                  <a:srgbClr val="152F2C"/>
-                </a:solidFill>
-                <a:latin typeface="Arial"/>
-                <a:ea typeface="Arial"/>
-                <a:cs typeface="Arial"/>
+                  <a:srgbClr val="191F28"/>
+                </a:solidFill>
+                <a:latin typeface="Segoe UI"/>
+                <a:ea typeface="Segoe UI"/>
+                <a:cs typeface="Segoe UI"/>
               </a:defRPr>
             </a:pPr>
             <a:r>
               <a:rPr sz="2250" b="0">
                 <a:solidFill>
-                  <a:srgbClr val="152F2C"/>
-                </a:solidFill>
-                <a:latin typeface="Arial"/>
-                <a:ea typeface="Arial"/>
-                <a:cs typeface="Arial"/>
+                  <a:srgbClr val="191F28"/>
+                </a:solidFill>
+                <a:latin typeface="Segoe UI"/>
+                <a:ea typeface="Segoe UI"/>
+                <a:cs typeface="Segoe UI"/>
               </a:rPr>
               <a:t>Native wallet bridge</a:t>
             </a:r>
@@ -4375,21 +4362,21 @@
             <a:pPr>
               <a:defRPr sz="2250" b="0">
                 <a:solidFill>
-                  <a:srgbClr val="152F2C"/>
-                </a:solidFill>
-                <a:latin typeface="Arial"/>
-                <a:ea typeface="Arial"/>
-                <a:cs typeface="Arial"/>
+                  <a:srgbClr val="191F28"/>
+                </a:solidFill>
+                <a:latin typeface="Segoe UI"/>
+                <a:ea typeface="Segoe UI"/>
+                <a:cs typeface="Segoe UI"/>
               </a:defRPr>
             </a:pPr>
             <a:r>
               <a:rPr sz="2250" b="0">
                 <a:solidFill>
-                  <a:srgbClr val="152F2C"/>
-                </a:solidFill>
-                <a:latin typeface="Arial"/>
-                <a:ea typeface="Arial"/>
-                <a:cs typeface="Arial"/>
+                  <a:srgbClr val="191F28"/>
+                </a:solidFill>
+                <a:latin typeface="Segoe UI"/>
+                <a:ea typeface="Segoe UI"/>
+                <a:cs typeface="Segoe UI"/>
               </a:rPr>
               <a:t>Direct read-only activity path</a:t>
             </a:r>
@@ -4401,7 +4388,7 @@
           <p:cNvPr id="4" name="">
             <a:extLst xmlns:a="http://schemas.openxmlformats.org/drawingml/2006/main">
               <a:ext uri="{FF2B5EF4-FFF2-40B4-BE49-F238E27FC236}">
-                <a16:creationId xmlns:a16="http://schemas.microsoft.com/office/drawing/2014/main" id="{2E93401B-41D7-4E70-A8B4-4FC528E7D911}"/>
+                <a16:creationId xmlns:a16="http://schemas.microsoft.com/office/drawing/2014/main" id="{BDAA8A93-3761-4F5E-86F2-CA90F7784532}"/>
               </a:ext>
             </a:extLst>
           </p:cNvPr>
@@ -4432,21 +4419,21 @@
             <a:pPr>
               <a:defRPr sz="2700" b="1">
                 <a:solidFill>
-                  <a:srgbClr val="152F2C"/>
-                </a:solidFill>
-                <a:latin typeface="Arial"/>
-                <a:ea typeface="Arial"/>
-                <a:cs typeface="Arial"/>
+                  <a:srgbClr val="191F28"/>
+                </a:solidFill>
+                <a:latin typeface="Segoe UI"/>
+                <a:ea typeface="Segoe UI"/>
+                <a:cs typeface="Segoe UI"/>
               </a:defRPr>
             </a:pPr>
             <a:r>
               <a:rPr sz="2700" b="1">
                 <a:solidFill>
-                  <a:srgbClr val="152F2C"/>
-                </a:solidFill>
-                <a:latin typeface="Arial"/>
-                <a:ea typeface="Arial"/>
-                <a:cs typeface="Arial"/>
+                  <a:srgbClr val="191F28"/>
+                </a:solidFill>
+                <a:latin typeface="Segoe UI"/>
+                <a:ea typeface="Segoe UI"/>
+                <a:cs typeface="Segoe UI"/>
               </a:rPr>
               <a:t>Open release gates</a:t>
             </a:r>
@@ -4458,7 +4445,7 @@
           <p:cNvPr id="5" name="">
             <a:extLst xmlns:a="http://schemas.openxmlformats.org/drawingml/2006/main">
               <a:ext uri="{FF2B5EF4-FFF2-40B4-BE49-F238E27FC236}">
-                <a16:creationId xmlns:a16="http://schemas.microsoft.com/office/drawing/2014/main" id="{58B08759-4BFC-461B-9037-FAAB0612E5C5}"/>
+                <a16:creationId xmlns:a16="http://schemas.microsoft.com/office/drawing/2014/main" id="{D4616195-E147-45E2-9B1E-8FB4A762E4D5}"/>
               </a:ext>
             </a:extLst>
           </p:cNvPr>
@@ -4489,44 +4476,44 @@
             <a:pPr>
               <a:defRPr sz="2250" b="0">
                 <a:solidFill>
-                  <a:srgbClr val="152F2C"/>
-                </a:solidFill>
-                <a:latin typeface="Arial"/>
-                <a:ea typeface="Arial"/>
-                <a:cs typeface="Arial"/>
+                  <a:srgbClr val="191F28"/>
+                </a:solidFill>
+                <a:latin typeface="Segoe UI"/>
+                <a:ea typeface="Segoe UI"/>
+                <a:cs typeface="Segoe UI"/>
               </a:defRPr>
             </a:pPr>
             <a:r>
               <a:rPr sz="2250" b="0">
                 <a:solidFill>
-                  <a:srgbClr val="152F2C"/>
-                </a:solidFill>
-                <a:latin typeface="Arial"/>
-                <a:ea typeface="Arial"/>
-                <a:cs typeface="Arial"/>
-              </a:rPr>
-              <a:t>Real-wallet device evidence</a:t>
+                  <a:srgbClr val="191F28"/>
+                </a:solidFill>
+                <a:latin typeface="Segoe UI"/>
+                <a:ea typeface="Segoe UI"/>
+                <a:cs typeface="Segoe UI"/>
+              </a:rPr>
+              <a:t>Physical Seeker + live activity</a:t>
             </a:r>
           </a:p>
           <a:p xmlns:a="http://schemas.openxmlformats.org/drawingml/2006/main">
             <a:pPr>
               <a:defRPr sz="2250" b="0">
                 <a:solidFill>
-                  <a:srgbClr val="152F2C"/>
-                </a:solidFill>
-                <a:latin typeface="Arial"/>
-                <a:ea typeface="Arial"/>
-                <a:cs typeface="Arial"/>
+                  <a:srgbClr val="191F28"/>
+                </a:solidFill>
+                <a:latin typeface="Segoe UI"/>
+                <a:ea typeface="Segoe UI"/>
+                <a:cs typeface="Segoe UI"/>
               </a:defRPr>
             </a:pPr>
             <a:r>
               <a:rPr sz="2250" b="0">
                 <a:solidFill>
-                  <a:srgbClr val="152F2C"/>
-                </a:solidFill>
-                <a:latin typeface="Arial"/>
-                <a:ea typeface="Arial"/>
-                <a:cs typeface="Arial"/>
+                  <a:srgbClr val="191F28"/>
+                </a:solidFill>
+                <a:latin typeface="Segoe UI"/>
+                <a:ea typeface="Segoe UI"/>
+                <a:cs typeface="Segoe UI"/>
               </a:rPr>
               <a:t>Fluent-speaker review</a:t>
             </a:r>
@@ -4535,21 +4522,21 @@
             <a:pPr>
               <a:defRPr sz="2250" b="0">
                 <a:solidFill>
-                  <a:srgbClr val="152F2C"/>
-                </a:solidFill>
-                <a:latin typeface="Arial"/>
-                <a:ea typeface="Arial"/>
-                <a:cs typeface="Arial"/>
+                  <a:srgbClr val="191F28"/>
+                </a:solidFill>
+                <a:latin typeface="Segoe UI"/>
+                <a:ea typeface="Segoe UI"/>
+                <a:cs typeface="Segoe UI"/>
               </a:defRPr>
             </a:pPr>
             <a:r>
               <a:rPr sz="2250" b="0">
                 <a:solidFill>
-                  <a:srgbClr val="152F2C"/>
-                </a:solidFill>
-                <a:latin typeface="Arial"/>
-                <a:ea typeface="Arial"/>
-                <a:cs typeface="Arial"/>
+                  <a:srgbClr val="191F28"/>
+                </a:solidFill>
+                <a:latin typeface="Segoe UI"/>
+                <a:ea typeface="Segoe UI"/>
+                <a:cs typeface="Segoe UI"/>
               </a:rPr>
               <a:t>Production RPC strategy</a:t>
             </a:r>
@@ -4558,21 +4545,21 @@
             <a:pPr>
               <a:defRPr sz="2250" b="0">
                 <a:solidFill>
-                  <a:srgbClr val="152F2C"/>
-                </a:solidFill>
-                <a:latin typeface="Arial"/>
-                <a:ea typeface="Arial"/>
-                <a:cs typeface="Arial"/>
+                  <a:srgbClr val="191F28"/>
+                </a:solidFill>
+                <a:latin typeface="Segoe UI"/>
+                <a:ea typeface="Segoe UI"/>
+                <a:cs typeface="Segoe UI"/>
               </a:defRPr>
             </a:pPr>
             <a:r>
               <a:rPr sz="2250" b="0">
                 <a:solidFill>
-                  <a:srgbClr val="152F2C"/>
-                </a:solidFill>
-                <a:latin typeface="Arial"/>
-                <a:ea typeface="Arial"/>
-                <a:cs typeface="Arial"/>
+                  <a:srgbClr val="191F28"/>
+                </a:solidFill>
+                <a:latin typeface="Segoe UI"/>
+                <a:ea typeface="Segoe UI"/>
+                <a:cs typeface="Segoe UI"/>
               </a:rPr>
               <a:t>Production signing</a:t>
             </a:r>
@@ -4584,7 +4571,7 @@
           <p:cNvPr id="6" name="">
             <a:extLst xmlns:a="http://schemas.openxmlformats.org/drawingml/2006/main">
               <a:ext uri="{FF2B5EF4-FFF2-40B4-BE49-F238E27FC236}">
-                <a16:creationId xmlns:a16="http://schemas.microsoft.com/office/drawing/2014/main" id="{5BBB1A44-C32C-43BC-AFDA-D0BD46862DFB}"/>
+                <a16:creationId xmlns:a16="http://schemas.microsoft.com/office/drawing/2014/main" id="{913D686B-2D79-4CE8-83C6-A8E59B89CCF0}"/>
               </a:ext>
             </a:extLst>
           </p:cNvPr>
@@ -4615,23 +4602,23 @@
             <a:pPr>
               <a:defRPr sz="1725" b="0">
                 <a:solidFill>
-                  <a:srgbClr val="526762"/>
-                </a:solidFill>
-                <a:latin typeface="Arial"/>
-                <a:ea typeface="Arial"/>
-                <a:cs typeface="Arial"/>
+                  <a:srgbClr val="667085"/>
+                </a:solidFill>
+                <a:latin typeface="Segoe UI"/>
+                <a:ea typeface="Segoe UI"/>
+                <a:cs typeface="Segoe UI"/>
               </a:defRPr>
             </a:pPr>
             <a:r>
               <a:rPr sz="1725" b="0">
                 <a:solidFill>
-                  <a:srgbClr val="526762"/>
-                </a:solidFill>
-                <a:latin typeface="Arial"/>
-                <a:ea typeface="Arial"/>
-                <a:cs typeface="Arial"/>
-              </a:rPr>
-              <a:t>Local and emulator evidence is retained. Fixtures are not live trading evidence.</a:t>
+                  <a:srgbClr val="667085"/>
+                </a:solidFill>
+                <a:latin typeface="Segoe UI"/>
+                <a:ea typeface="Segoe UI"/>
+                <a:cs typeface="Segoe UI"/>
+              </a:rPr>
+              <a:t>88 app tests pass. Manual mock-wallet connection verified. Fixtures are not live trading evidence.</a:t>
             </a:r>
           </a:p>
         </p:txBody>
@@ -4641,7 +4628,7 @@
           <p:cNvPr id="7" name="">
             <a:extLst xmlns:a="http://schemas.openxmlformats.org/drawingml/2006/main">
               <a:ext uri="{FF2B5EF4-FFF2-40B4-BE49-F238E27FC236}">
-                <a16:creationId xmlns:a16="http://schemas.microsoft.com/office/drawing/2014/main" id="{8A4F3F28-6BF5-4713-AABC-DA617E97F0EB}"/>
+                <a16:creationId xmlns:a16="http://schemas.microsoft.com/office/drawing/2014/main" id="{6E8DCF3D-54F4-450B-BE34-1284C5F94315}"/>
               </a:ext>
             </a:extLst>
           </p:cNvPr>
@@ -4672,21 +4659,21 @@
             <a:pPr>
               <a:defRPr sz="1200" b="0">
                 <a:solidFill>
-                  <a:srgbClr val="526762"/>
-                </a:solidFill>
-                <a:latin typeface="Arial"/>
-                <a:ea typeface="Arial"/>
-                <a:cs typeface="Arial"/>
+                  <a:srgbClr val="667085"/>
+                </a:solidFill>
+                <a:latin typeface="Segoe UI"/>
+                <a:ea typeface="Segoe UI"/>
+                <a:cs typeface="Segoe UI"/>
               </a:defRPr>
             </a:pPr>
             <a:r>
               <a:rPr sz="1200" b="0">
                 <a:solidFill>
-                  <a:srgbClr val="526762"/>
-                </a:solidFill>
-                <a:latin typeface="Arial"/>
-                <a:ea typeface="Arial"/>
-                <a:cs typeface="Arial"/>
+                  <a:srgbClr val="667085"/>
+                </a:solidFill>
+                <a:latin typeface="Segoe UI"/>
+                <a:ea typeface="Segoe UI"/>
+                <a:cs typeface="Segoe UI"/>
               </a:rPr>
               <a:t>FOR THE RECORD   /   07</a:t>
             </a:r>
@@ -4696,7 +4683,7 @@
     </p:spTree>
     <p:extLst>
       <p:ext uri="{BB962C8B-B14F-4D97-AF65-F5344CB8AC3E}">
-        <p14:creationId xmlns:p14="http://schemas.microsoft.com/office/powerpoint/2010/main" val="82969481"/>
+        <p14:creationId xmlns:p14="http://schemas.microsoft.com/office/powerpoint/2010/main" val="1130266552"/>
       </p:ext>
     </p:extLst>
   </p:cSld>
@@ -4709,7 +4696,7 @@
     <p:bg>
       <p:bgPr>
         <a:solidFill xmlns:a="http://schemas.openxmlformats.org/drawingml/2006/main">
-          <a:srgbClr val="096B61"/>
+          <a:srgbClr val="191F28"/>
         </a:solidFill>
       </p:bgPr>
     </p:bg>
@@ -4727,7 +4714,7 @@
           <p:cNvPr id="6" name="">
             <a:extLst xmlns:a="http://schemas.openxmlformats.org/drawingml/2006/main">
               <a:ext uri="{FF2B5EF4-FFF2-40B4-BE49-F238E27FC236}">
-                <a16:creationId xmlns:a16="http://schemas.microsoft.com/office/drawing/2014/main" id="{BE3E7926-92DD-4AB9-A493-797BDF182A8C}"/>
+                <a16:creationId xmlns:a16="http://schemas.microsoft.com/office/drawing/2014/main" id="{7653E24F-3DEA-48C3-B1C2-7179F300BD35}"/>
               </a:ext>
             </a:extLst>
           </p:cNvPr>
@@ -4739,7 +4726,7 @@
         <p:spPr>
           <a:xfrm xmlns:a="http://schemas.openxmlformats.org/drawingml/2006/main">
             <a:off x="685800" y="714375"/>
-            <a:ext cx="10763250" cy="809625"/>
+            <a:ext cx="10763250" cy="1238250"/>
           </a:xfrm>
           <a:prstGeom xmlns:a="http://schemas.openxmlformats.org/drawingml/2006/main" prst="rect">
             <a:avLst/>
@@ -4756,25 +4743,25 @@
           <a:lstStyle xmlns:a="http://schemas.openxmlformats.org/drawingml/2006/main"/>
           <a:p xmlns:a="http://schemas.openxmlformats.org/drawingml/2006/main">
             <a:pPr>
-              <a:defRPr sz="4125" b="1">
-                <a:solidFill>
-                  <a:srgbClr val="F2FFCE"/>
-                </a:solidFill>
-                <a:latin typeface="Arial"/>
-                <a:ea typeface="Arial"/>
-                <a:cs typeface="Arial"/>
-              </a:defRPr>
-            </a:pPr>
-            <a:r>
-              <a:rPr sz="4125" b="1">
-                <a:solidFill>
-                  <a:srgbClr val="F2FFCE"/>
-                </a:solidFill>
-                <a:latin typeface="Arial"/>
-                <a:ea typeface="Arial"/>
-                <a:cs typeface="Arial"/>
-              </a:rPr>
-              <a:t>The next release gate</a:t>
+              <a:defRPr sz="3825" b="1">
+                <a:solidFill>
+                  <a:srgbClr val="FFFFFF"/>
+                </a:solidFill>
+                <a:latin typeface="Segoe UI"/>
+                <a:ea typeface="Segoe UI"/>
+                <a:cs typeface="Segoe UI"/>
+              </a:defRPr>
+            </a:pPr>
+            <a:r>
+              <a:rPr sz="3825" b="1">
+                <a:solidFill>
+                  <a:srgbClr val="FFFFFF"/>
+                </a:solidFill>
+                <a:latin typeface="Segoe UI"/>
+                <a:ea typeface="Segoe UI"/>
+                <a:cs typeface="Segoe UI"/>
+              </a:rPr>
+              <a:t>Leave tomorrow a starting point.</a:t>
             </a:r>
           </a:p>
         </p:txBody>
@@ -4784,7 +4771,7 @@
           <p:cNvPr id="2" name="">
             <a:extLst xmlns:a="http://schemas.openxmlformats.org/drawingml/2006/main">
               <a:ext uri="{FF2B5EF4-FFF2-40B4-BE49-F238E27FC236}">
-                <a16:creationId xmlns:a16="http://schemas.microsoft.com/office/drawing/2014/main" id="{EA64B063-029B-49DA-A965-337DD44F698F}"/>
+                <a16:creationId xmlns:a16="http://schemas.microsoft.com/office/drawing/2014/main" id="{EC809C49-299D-48B7-86ED-D2F916FC408E}"/>
               </a:ext>
             </a:extLst>
           </p:cNvPr>
@@ -4795,8 +4782,8 @@
         </p:nvSpPr>
         <p:spPr>
           <a:xfrm xmlns:a="http://schemas.openxmlformats.org/drawingml/2006/main">
-            <a:off x="685800" y="2105025"/>
-            <a:ext cx="10620375" cy="2190750"/>
+            <a:off x="685800" y="2295525"/>
+            <a:ext cx="10620375" cy="2143125"/>
           </a:xfrm>
           <a:prstGeom xmlns:a="http://schemas.openxmlformats.org/drawingml/2006/main" prst="rect">
             <a:avLst/>
@@ -4813,71 +4800,71 @@
           <a:lstStyle xmlns:a="http://schemas.openxmlformats.org/drawingml/2006/main"/>
           <a:p xmlns:a="http://schemas.openxmlformats.org/drawingml/2006/main">
             <a:pPr>
-              <a:defRPr sz="3525" b="1">
-                <a:solidFill>
-                  <a:srgbClr val="FFFEFA"/>
-                </a:solidFill>
-                <a:latin typeface="Arial"/>
-                <a:ea typeface="Arial"/>
-                <a:cs typeface="Arial"/>
-              </a:defRPr>
-            </a:pPr>
-            <a:r>
-              <a:rPr sz="3525" b="1">
-                <a:solidFill>
-                  <a:srgbClr val="FFFEFA"/>
-                </a:solidFill>
-                <a:latin typeface="Arial"/>
-                <a:ea typeface="Arial"/>
-                <a:cs typeface="Arial"/>
-              </a:rPr>
-              <a:t>Prove wallet reads on a device.</a:t>
-            </a:r>
-          </a:p>
-          <a:p xmlns:a="http://schemas.openxmlformats.org/drawingml/2006/main">
-            <a:pPr>
-              <a:defRPr sz="3525" b="1">
-                <a:solidFill>
-                  <a:srgbClr val="FFFEFA"/>
-                </a:solidFill>
-                <a:latin typeface="Arial"/>
-                <a:ea typeface="Arial"/>
-                <a:cs typeface="Arial"/>
-              </a:defRPr>
-            </a:pPr>
-            <a:r>
-              <a:rPr sz="3525" b="1">
-                <a:solidFill>
-                  <a:srgbClr val="FFFEFA"/>
-                </a:solidFill>
-                <a:latin typeface="Arial"/>
-                <a:ea typeface="Arial"/>
-                <a:cs typeface="Arial"/>
-              </a:rPr>
-              <a:t>Record the verified live flow.</a:t>
-            </a:r>
-          </a:p>
-          <a:p xmlns:a="http://schemas.openxmlformats.org/drawingml/2006/main">
-            <a:pPr>
-              <a:defRPr sz="3525" b="1">
-                <a:solidFill>
-                  <a:srgbClr val="FFFEFA"/>
-                </a:solidFill>
-                <a:latin typeface="Arial"/>
-                <a:ea typeface="Arial"/>
-                <a:cs typeface="Arial"/>
-              </a:defRPr>
-            </a:pPr>
-            <a:r>
-              <a:rPr sz="3525" b="1">
-                <a:solidFill>
-                  <a:srgbClr val="FFFEFA"/>
-                </a:solidFill>
-                <a:latin typeface="Arial"/>
-                <a:ea typeface="Arial"/>
-                <a:cs typeface="Arial"/>
-              </a:rPr>
-              <a:t>Prepare the dApp Store release.</a:t>
+              <a:defRPr sz="3300" b="1">
+                <a:solidFill>
+                  <a:srgbClr val="FFFFFF"/>
+                </a:solidFill>
+                <a:latin typeface="Segoe UI"/>
+                <a:ea typeface="Segoe UI"/>
+                <a:cs typeface="Segoe UI"/>
+              </a:defRPr>
+            </a:pPr>
+            <a:r>
+              <a:rPr sz="3300" b="1">
+                <a:solidFill>
+                  <a:srgbClr val="FFFFFF"/>
+                </a:solidFill>
+                <a:latin typeface="Segoe UI"/>
+                <a:ea typeface="Segoe UI"/>
+                <a:cs typeface="Segoe UI"/>
+              </a:rPr>
+              <a:t>Keep the intention.</a:t>
+            </a:r>
+          </a:p>
+          <a:p xmlns:a="http://schemas.openxmlformats.org/drawingml/2006/main">
+            <a:pPr>
+              <a:defRPr sz="3300" b="1">
+                <a:solidFill>
+                  <a:srgbClr val="FFFFFF"/>
+                </a:solidFill>
+                <a:latin typeface="Segoe UI"/>
+                <a:ea typeface="Segoe UI"/>
+                <a:cs typeface="Segoe UI"/>
+              </a:defRPr>
+            </a:pPr>
+            <a:r>
+              <a:rPr sz="3300" b="1">
+                <a:solidFill>
+                  <a:srgbClr val="FFFFFF"/>
+                </a:solidFill>
+                <a:latin typeface="Segoe UI"/>
+                <a:ea typeface="Segoe UI"/>
+                <a:cs typeface="Segoe UI"/>
+              </a:rPr>
+              <a:t>Remember the reason.</a:t>
+            </a:r>
+          </a:p>
+          <a:p xmlns:a="http://schemas.openxmlformats.org/drawingml/2006/main">
+            <a:pPr>
+              <a:defRPr sz="3300" b="1">
+                <a:solidFill>
+                  <a:srgbClr val="FFFFFF"/>
+                </a:solidFill>
+                <a:latin typeface="Segoe UI"/>
+                <a:ea typeface="Segoe UI"/>
+                <a:cs typeface="Segoe UI"/>
+              </a:defRPr>
+            </a:pPr>
+            <a:r>
+              <a:rPr sz="3300" b="1">
+                <a:solidFill>
+                  <a:srgbClr val="FFFFFF"/>
+                </a:solidFill>
+                <a:latin typeface="Segoe UI"/>
+                <a:ea typeface="Segoe UI"/>
+                <a:cs typeface="Segoe UI"/>
+              </a:rPr>
+              <a:t>Return to a clear next action.</a:t>
             </a:r>
           </a:p>
         </p:txBody>
@@ -4887,7 +4874,7 @@
           <p:cNvPr id="3" name="">
             <a:extLst xmlns:a="http://schemas.openxmlformats.org/drawingml/2006/main">
               <a:ext uri="{FF2B5EF4-FFF2-40B4-BE49-F238E27FC236}">
-                <a16:creationId xmlns:a16="http://schemas.microsoft.com/office/drawing/2014/main" id="{F7D08898-DE0C-4913-B398-B23A24C07BAF}"/>
+                <a16:creationId xmlns:a16="http://schemas.microsoft.com/office/drawing/2014/main" id="{777D23BA-6ABE-4C9F-B177-EC22E0C05F56}"/>
               </a:ext>
             </a:extLst>
           </p:cNvPr>
@@ -4898,8 +4885,8 @@
         </p:nvSpPr>
         <p:spPr>
           <a:xfrm xmlns:a="http://schemas.openxmlformats.org/drawingml/2006/main">
-            <a:off x="685800" y="4695825"/>
-            <a:ext cx="10572750" cy="619125"/>
+            <a:off x="685800" y="4876800"/>
+            <a:ext cx="10572750" cy="628650"/>
           </a:xfrm>
           <a:prstGeom xmlns:a="http://schemas.openxmlformats.org/drawingml/2006/main" prst="rect">
             <a:avLst/>
@@ -4916,25 +4903,25 @@
           <a:lstStyle xmlns:a="http://schemas.openxmlformats.org/drawingml/2006/main"/>
           <a:p xmlns:a="http://schemas.openxmlformats.org/drawingml/2006/main">
             <a:pPr>
-              <a:defRPr sz="2175" b="0">
-                <a:solidFill>
-                  <a:srgbClr val="FFFEFA"/>
-                </a:solidFill>
-                <a:latin typeface="Arial"/>
-                <a:ea typeface="Arial"/>
-                <a:cs typeface="Arial"/>
-              </a:defRPr>
-            </a:pPr>
-            <a:r>
-              <a:rPr sz="2175" b="0">
-                <a:solidFill>
-                  <a:srgbClr val="FFFEFA"/>
-                </a:solidFill>
-                <a:latin typeface="Arial"/>
-                <a:ea typeface="Arial"/>
-                <a:cs typeface="Arial"/>
-              </a:rPr>
-              <a:t>Then test whether users return to their next action.</a:t>
+              <a:defRPr sz="1875" b="0">
+                <a:solidFill>
+                  <a:srgbClr val="D5F56B"/>
+                </a:solidFill>
+                <a:latin typeface="Segoe UI"/>
+                <a:ea typeface="Segoe UI"/>
+                <a:cs typeface="Segoe UI"/>
+              </a:defRPr>
+            </a:pPr>
+            <a:r>
+              <a:rPr sz="1875" b="0">
+                <a:solidFill>
+                  <a:srgbClr val="D5F56B"/>
+                </a:solidFill>
+                <a:latin typeface="Segoe UI"/>
+                <a:ea typeface="Segoe UI"/>
+                <a:cs typeface="Segoe UI"/>
+              </a:rPr>
+              <a:t>Next: verify live activity on Seeker, then learn from returning users.</a:t>
             </a:r>
           </a:p>
         </p:txBody>
@@ -4944,7 +4931,7 @@
           <p:cNvPr id="4" name="">
             <a:extLst xmlns:a="http://schemas.openxmlformats.org/drawingml/2006/main">
               <a:ext uri="{FF2B5EF4-FFF2-40B4-BE49-F238E27FC236}">
-                <a16:creationId xmlns:a16="http://schemas.microsoft.com/office/drawing/2014/main" id="{87DA70EB-2EB1-42FB-BD2C-17D149B5EF16}"/>
+                <a16:creationId xmlns:a16="http://schemas.microsoft.com/office/drawing/2014/main" id="{630F1649-7357-40DB-8F1B-EBA87418AA49}"/>
               </a:ext>
             </a:extLst>
           </p:cNvPr>
@@ -4975,21 +4962,21 @@
             <a:pPr>
               <a:defRPr sz="1875" b="0">
                 <a:solidFill>
-                  <a:srgbClr val="F2FFCE"/>
-                </a:solidFill>
-                <a:latin typeface="Arial"/>
-                <a:ea typeface="Arial"/>
-                <a:cs typeface="Arial"/>
+                  <a:srgbClr val="D5F56B"/>
+                </a:solidFill>
+                <a:latin typeface="Segoe UI"/>
+                <a:ea typeface="Segoe UI"/>
+                <a:cs typeface="Segoe UI"/>
               </a:defRPr>
             </a:pPr>
             <a:r>
               <a:rPr sz="1875" b="0">
                 <a:solidFill>
-                  <a:srgbClr val="F2FFCE"/>
-                </a:solidFill>
-                <a:latin typeface="Arial"/>
-                <a:ea typeface="Arial"/>
-                <a:cs typeface="Arial"/>
+                  <a:srgbClr val="D5F56B"/>
+                </a:solidFill>
+                <a:latin typeface="Segoe UI"/>
+                <a:ea typeface="Segoe UI"/>
+                <a:cs typeface="Segoe UI"/>
               </a:rPr>
               <a:t>workroom-seeker-6984.web.app</a:t>
             </a:r>
@@ -5001,7 +4988,7 @@
           <p:cNvPr id="5" name="">
             <a:extLst xmlns:a="http://schemas.openxmlformats.org/drawingml/2006/main">
               <a:ext uri="{FF2B5EF4-FFF2-40B4-BE49-F238E27FC236}">
-                <a16:creationId xmlns:a16="http://schemas.microsoft.com/office/drawing/2014/main" id="{52070EA6-4CDA-4F0C-8BA3-64553AFAF949}"/>
+                <a16:creationId xmlns:a16="http://schemas.microsoft.com/office/drawing/2014/main" id="{719F52A1-C387-45AB-8BF5-0B5B965C02FB}"/>
               </a:ext>
             </a:extLst>
           </p:cNvPr>
@@ -5032,21 +5019,21 @@
             <a:pPr>
               <a:defRPr sz="1200" b="0">
                 <a:solidFill>
-                  <a:srgbClr val="F2FFCE"/>
-                </a:solidFill>
-                <a:latin typeface="Arial"/>
-                <a:ea typeface="Arial"/>
-                <a:cs typeface="Arial"/>
+                  <a:srgbClr val="D5F56B"/>
+                </a:solidFill>
+                <a:latin typeface="Segoe UI"/>
+                <a:ea typeface="Segoe UI"/>
+                <a:cs typeface="Segoe UI"/>
               </a:defRPr>
             </a:pPr>
             <a:r>
               <a:rPr sz="1200" b="0">
                 <a:solidFill>
-                  <a:srgbClr val="F2FFCE"/>
-                </a:solidFill>
-                <a:latin typeface="Arial"/>
-                <a:ea typeface="Arial"/>
-                <a:cs typeface="Arial"/>
+                  <a:srgbClr val="D5F56B"/>
+                </a:solidFill>
+                <a:latin typeface="Segoe UI"/>
+                <a:ea typeface="Segoe UI"/>
+                <a:cs typeface="Segoe UI"/>
               </a:rPr>
               <a:t>FOR THE RECORD   /   08</a:t>
             </a:r>
@@ -5056,7 +5043,7 @@
     </p:spTree>
     <p:extLst>
       <p:ext uri="{BB962C8B-B14F-4D97-AF65-F5344CB8AC3E}">
-        <p14:creationId xmlns:p14="http://schemas.microsoft.com/office/powerpoint/2010/main" val="1872874689"/>
+        <p14:creationId xmlns:p14="http://schemas.microsoft.com/office/powerpoint/2010/main" val="1580182774"/>
       </p:ext>
     </p:extLst>
   </p:cSld>

</xml_diff>